<commit_message>
Update training slides (adds Module 1c and Module 3)
Co-Authored-By: Claude Opus 4.8 <noreply@anthropic.com>
</commit_message>
<xml_diff>
--- a/UChicago-PME-AI-Training.pptx
+++ b/UChicago-PME-AI-Training.pptx
@@ -5,7 +5,7 @@
     <p:sldMasterId id="2147483648" r:id="rId1"/>
   </p:sldMasterIdLst>
   <p:notesMasterIdLst>
-    <p:notesMasterId r:id="rId17"/>
+    <p:notesMasterId r:id="rId21"/>
   </p:notesMasterIdLst>
   <p:sldIdLst>
     <p:sldId id="256" r:id="rId2"/>
@@ -16,13 +16,17 @@
     <p:sldId id="261" r:id="rId7"/>
     <p:sldId id="262" r:id="rId8"/>
     <p:sldId id="263" r:id="rId9"/>
-    <p:sldId id="264" r:id="rId10"/>
-    <p:sldId id="265" r:id="rId11"/>
-    <p:sldId id="271" r:id="rId12"/>
-    <p:sldId id="266" r:id="rId13"/>
-    <p:sldId id="267" r:id="rId14"/>
-    <p:sldId id="268" r:id="rId15"/>
-    <p:sldId id="269" r:id="rId16"/>
+    <p:sldId id="272" r:id="rId10"/>
+    <p:sldId id="273" r:id="rId11"/>
+    <p:sldId id="264" r:id="rId12"/>
+    <p:sldId id="265" r:id="rId13"/>
+    <p:sldId id="271" r:id="rId14"/>
+    <p:sldId id="266" r:id="rId15"/>
+    <p:sldId id="267" r:id="rId16"/>
+    <p:sldId id="268" r:id="rId17"/>
+    <p:sldId id="269" r:id="rId18"/>
+    <p:sldId id="274" r:id="rId19"/>
+    <p:sldId id="275" r:id="rId20"/>
   </p:sldIdLst>
   <p:sldSz cx="12192000" cy="6858000"/>
   <p:notesSz cx="6858000" cy="12192000"/>
@@ -340,7 +344,13 @@
   <p:cSld>
     <p:spTree>
       <p:nvGrpSpPr>
-        <p:cNvPr id="1" name=""/>
+        <p:cNvPr id="1" name="">
+          <a:extLst>
+            <a:ext uri="{FF2B5EF4-FFF2-40B4-BE49-F238E27FC236}">
+              <a16:creationId xmlns:a16="http://schemas.microsoft.com/office/drawing/2014/main" id="{CC4254FF-0FE7-4A88-D06A-E608C62BCD41}"/>
+            </a:ext>
+          </a:extLst>
+        </p:cNvPr>
         <p:cNvGrpSpPr/>
         <p:nvPr/>
       </p:nvGrpSpPr>
@@ -354,7 +364,13 @@
       </p:grpSpPr>
       <p:sp>
         <p:nvSpPr>
-          <p:cNvPr id="2" name="Slide Image Placeholder 1"/>
+          <p:cNvPr id="2" name="Slide Image Placeholder 1">
+            <a:extLst>
+              <a:ext uri="{FF2B5EF4-FFF2-40B4-BE49-F238E27FC236}">
+                <a16:creationId xmlns:a16="http://schemas.microsoft.com/office/drawing/2014/main" id="{3E6F6A0B-0D89-DA52-B0BD-7DAF24B67BA9}"/>
+              </a:ext>
+            </a:extLst>
+          </p:cNvPr>
           <p:cNvSpPr>
             <a:spLocks noGrp="1" noRot="1" noChangeAspect="1"/>
           </p:cNvSpPr>
@@ -366,7 +382,13 @@
       </p:sp>
       <p:sp>
         <p:nvSpPr>
-          <p:cNvPr id="3" name="Notes Placeholder 2"/>
+          <p:cNvPr id="3" name="Notes Placeholder 2">
+            <a:extLst>
+              <a:ext uri="{FF2B5EF4-FFF2-40B4-BE49-F238E27FC236}">
+                <a16:creationId xmlns:a16="http://schemas.microsoft.com/office/drawing/2014/main" id="{E03E9BF2-4ABF-8CA1-6610-7E7EDA687E4B}"/>
+              </a:ext>
+            </a:extLst>
+          </p:cNvPr>
           <p:cNvSpPr>
             <a:spLocks noGrp="1"/>
           </p:cNvSpPr>
@@ -385,7 +407,13 @@
       </p:sp>
       <p:sp>
         <p:nvSpPr>
-          <p:cNvPr id="4" name="Slide Number Placeholder 3"/>
+          <p:cNvPr id="4" name="Slide Number Placeholder 3">
+            <a:extLst>
+              <a:ext uri="{FF2B5EF4-FFF2-40B4-BE49-F238E27FC236}">
+                <a16:creationId xmlns:a16="http://schemas.microsoft.com/office/drawing/2014/main" id="{7952E23D-35B4-4468-9C70-F37F777FE029}"/>
+              </a:ext>
+            </a:extLst>
+          </p:cNvPr>
           <p:cNvSpPr>
             <a:spLocks noGrp="1"/>
           </p:cNvSpPr>
@@ -409,7 +437,7 @@
     </p:spTree>
     <p:extLst>
       <p:ext uri="{BB962C8B-B14F-4D97-AF65-F5344CB8AC3E}">
-        <p14:creationId xmlns:p14="http://schemas.microsoft.com/office/powerpoint/2010/main" val="1024086991"/>
+        <p14:creationId xmlns:p14="http://schemas.microsoft.com/office/powerpoint/2010/main" val="2315957739"/>
       </p:ext>
     </p:extLst>
   </p:cSld>
@@ -424,13 +452,7 @@
   <p:cSld>
     <p:spTree>
       <p:nvGrpSpPr>
-        <p:cNvPr id="1" name="">
-          <a:extLst>
-            <a:ext uri="{FF2B5EF4-FFF2-40B4-BE49-F238E27FC236}">
-              <a16:creationId xmlns:a16="http://schemas.microsoft.com/office/drawing/2014/main" id="{BB09DC89-CCDF-1DBE-3B31-1A9C866DE8A6}"/>
-            </a:ext>
-          </a:extLst>
-        </p:cNvPr>
+        <p:cNvPr id="1" name=""/>
         <p:cNvGrpSpPr/>
         <p:nvPr/>
       </p:nvGrpSpPr>
@@ -444,13 +466,7 @@
       </p:grpSpPr>
       <p:sp>
         <p:nvSpPr>
-          <p:cNvPr id="2" name="Slide Image Placeholder 1">
-            <a:extLst>
-              <a:ext uri="{FF2B5EF4-FFF2-40B4-BE49-F238E27FC236}">
-                <a16:creationId xmlns:a16="http://schemas.microsoft.com/office/drawing/2014/main" id="{B0C2DDB1-6EE0-0C0A-6828-E666A0E64ECE}"/>
-              </a:ext>
-            </a:extLst>
-          </p:cNvPr>
+          <p:cNvPr id="2" name="Slide Image Placeholder 1"/>
           <p:cNvSpPr>
             <a:spLocks noGrp="1" noRot="1" noChangeAspect="1"/>
           </p:cNvSpPr>
@@ -462,13 +478,7 @@
       </p:sp>
       <p:sp>
         <p:nvSpPr>
-          <p:cNvPr id="3" name="Notes Placeholder 2">
-            <a:extLst>
-              <a:ext uri="{FF2B5EF4-FFF2-40B4-BE49-F238E27FC236}">
-                <a16:creationId xmlns:a16="http://schemas.microsoft.com/office/drawing/2014/main" id="{6D64CC37-C4A6-4FC6-304B-072D66CB0539}"/>
-              </a:ext>
-            </a:extLst>
-          </p:cNvPr>
+          <p:cNvPr id="3" name="Notes Placeholder 2"/>
           <p:cNvSpPr>
             <a:spLocks noGrp="1"/>
           </p:cNvSpPr>
@@ -487,13 +497,7 @@
       </p:sp>
       <p:sp>
         <p:nvSpPr>
-          <p:cNvPr id="4" name="Slide Number Placeholder 3">
-            <a:extLst>
-              <a:ext uri="{FF2B5EF4-FFF2-40B4-BE49-F238E27FC236}">
-                <a16:creationId xmlns:a16="http://schemas.microsoft.com/office/drawing/2014/main" id="{6102A303-6543-7A89-922A-EA83AAC97AE1}"/>
-              </a:ext>
-            </a:extLst>
-          </p:cNvPr>
+          <p:cNvPr id="4" name="Slide Number Placeholder 3"/>
           <p:cNvSpPr>
             <a:spLocks noGrp="1"/>
           </p:cNvSpPr>
@@ -517,7 +521,7 @@
     </p:spTree>
     <p:extLst>
       <p:ext uri="{BB962C8B-B14F-4D97-AF65-F5344CB8AC3E}">
-        <p14:creationId xmlns:p14="http://schemas.microsoft.com/office/powerpoint/2010/main" val="3050168391"/>
+        <p14:creationId xmlns:p14="http://schemas.microsoft.com/office/powerpoint/2010/main" val="1024086991"/>
       </p:ext>
     </p:extLst>
   </p:cSld>
@@ -616,7 +620,13 @@
   <p:cSld>
     <p:spTree>
       <p:nvGrpSpPr>
-        <p:cNvPr id="1" name=""/>
+        <p:cNvPr id="1" name="">
+          <a:extLst>
+            <a:ext uri="{FF2B5EF4-FFF2-40B4-BE49-F238E27FC236}">
+              <a16:creationId xmlns:a16="http://schemas.microsoft.com/office/drawing/2014/main" id="{BB09DC89-CCDF-1DBE-3B31-1A9C866DE8A6}"/>
+            </a:ext>
+          </a:extLst>
+        </p:cNvPr>
         <p:cNvGrpSpPr/>
         <p:nvPr/>
       </p:nvGrpSpPr>
@@ -630,7 +640,13 @@
       </p:grpSpPr>
       <p:sp>
         <p:nvSpPr>
-          <p:cNvPr id="2" name="Slide Image Placeholder 1"/>
+          <p:cNvPr id="2" name="Slide Image Placeholder 1">
+            <a:extLst>
+              <a:ext uri="{FF2B5EF4-FFF2-40B4-BE49-F238E27FC236}">
+                <a16:creationId xmlns:a16="http://schemas.microsoft.com/office/drawing/2014/main" id="{B0C2DDB1-6EE0-0C0A-6828-E666A0E64ECE}"/>
+              </a:ext>
+            </a:extLst>
+          </p:cNvPr>
           <p:cNvSpPr>
             <a:spLocks noGrp="1" noRot="1" noChangeAspect="1"/>
           </p:cNvSpPr>
@@ -642,7 +658,13 @@
       </p:sp>
       <p:sp>
         <p:nvSpPr>
-          <p:cNvPr id="3" name="Notes Placeholder 2"/>
+          <p:cNvPr id="3" name="Notes Placeholder 2">
+            <a:extLst>
+              <a:ext uri="{FF2B5EF4-FFF2-40B4-BE49-F238E27FC236}">
+                <a16:creationId xmlns:a16="http://schemas.microsoft.com/office/drawing/2014/main" id="{6D64CC37-C4A6-4FC6-304B-072D66CB0539}"/>
+              </a:ext>
+            </a:extLst>
+          </p:cNvPr>
           <p:cNvSpPr>
             <a:spLocks noGrp="1"/>
           </p:cNvSpPr>
@@ -661,7 +683,13 @@
       </p:sp>
       <p:sp>
         <p:nvSpPr>
-          <p:cNvPr id="4" name="Slide Number Placeholder 3"/>
+          <p:cNvPr id="4" name="Slide Number Placeholder 3">
+            <a:extLst>
+              <a:ext uri="{FF2B5EF4-FFF2-40B4-BE49-F238E27FC236}">
+                <a16:creationId xmlns:a16="http://schemas.microsoft.com/office/drawing/2014/main" id="{6102A303-6543-7A89-922A-EA83AAC97AE1}"/>
+              </a:ext>
+            </a:extLst>
+          </p:cNvPr>
           <p:cNvSpPr>
             <a:spLocks noGrp="1"/>
           </p:cNvSpPr>
@@ -685,7 +713,7 @@
     </p:spTree>
     <p:extLst>
       <p:ext uri="{BB962C8B-B14F-4D97-AF65-F5344CB8AC3E}">
-        <p14:creationId xmlns:p14="http://schemas.microsoft.com/office/powerpoint/2010/main" val="1024086991"/>
+        <p14:creationId xmlns:p14="http://schemas.microsoft.com/office/powerpoint/2010/main" val="3050168391"/>
       </p:ext>
     </p:extLst>
   </p:cSld>
@@ -863,6 +891,390 @@
 </p:notes>
 </file>
 
+<file path=ppt/notesSlides/notesSlide16.xml><?xml version="1.0" encoding="utf-8"?>
+<p:notes xmlns:a="http://schemas.openxmlformats.org/drawingml/2006/main" xmlns:r="http://schemas.openxmlformats.org/officeDocument/2006/relationships" xmlns:p="http://schemas.openxmlformats.org/presentationml/2006/main">
+  <p:cSld>
+    <p:spTree>
+      <p:nvGrpSpPr>
+        <p:cNvPr id="1" name=""/>
+        <p:cNvGrpSpPr/>
+        <p:nvPr/>
+      </p:nvGrpSpPr>
+      <p:grpSpPr>
+        <a:xfrm>
+          <a:off x="0" y="0"/>
+          <a:ext cx="0" cy="0"/>
+          <a:chOff x="0" y="0"/>
+          <a:chExt cx="0" cy="0"/>
+        </a:xfrm>
+      </p:grpSpPr>
+      <p:sp>
+        <p:nvSpPr>
+          <p:cNvPr id="2" name="Slide Image Placeholder 1"/>
+          <p:cNvSpPr>
+            <a:spLocks noGrp="1" noRot="1" noChangeAspect="1"/>
+          </p:cNvSpPr>
+          <p:nvPr>
+            <p:ph type="sldImg"/>
+          </p:nvPr>
+        </p:nvSpPr>
+        <p:spPr/>
+      </p:sp>
+      <p:sp>
+        <p:nvSpPr>
+          <p:cNvPr id="3" name="Notes Placeholder 2"/>
+          <p:cNvSpPr>
+            <a:spLocks noGrp="1"/>
+          </p:cNvSpPr>
+          <p:nvPr>
+            <p:ph type="body" idx="1"/>
+          </p:nvPr>
+        </p:nvSpPr>
+        <p:spPr/>
+        <p:txBody>
+          <a:bodyPr/>
+          <a:lstStyle/>
+          <a:p>
+            <a:endParaRPr lang="en-US" dirty="0"/>
+          </a:p>
+        </p:txBody>
+      </p:sp>
+      <p:sp>
+        <p:nvSpPr>
+          <p:cNvPr id="4" name="Slide Number Placeholder 3"/>
+          <p:cNvSpPr>
+            <a:spLocks noGrp="1"/>
+          </p:cNvSpPr>
+          <p:nvPr>
+            <p:ph type="sldNum" sz="quarter" idx="10"/>
+          </p:nvPr>
+        </p:nvSpPr>
+        <p:spPr/>
+        <p:txBody>
+          <a:bodyPr/>
+          <a:lstStyle/>
+          <a:p>
+            <a:fld id="{F7021451-1387-4CA6-816F-3879F97B5CBC}" type="slidenum">
+              <a:rPr lang="en-US"/>
+              <a:t>16</a:t>
+            </a:fld>
+            <a:endParaRPr lang="en-US"/>
+          </a:p>
+        </p:txBody>
+      </p:sp>
+    </p:spTree>
+    <p:extLst>
+      <p:ext uri="{BB962C8B-B14F-4D97-AF65-F5344CB8AC3E}">
+        <p14:creationId xmlns:p14="http://schemas.microsoft.com/office/powerpoint/2010/main" val="1024086991"/>
+      </p:ext>
+    </p:extLst>
+  </p:cSld>
+  <p:clrMapOvr>
+    <a:masterClrMapping/>
+  </p:clrMapOvr>
+</p:notes>
+</file>
+
+<file path=ppt/notesSlides/notesSlide17.xml><?xml version="1.0" encoding="utf-8"?>
+<p:notes xmlns:a="http://schemas.openxmlformats.org/drawingml/2006/main" xmlns:r="http://schemas.openxmlformats.org/officeDocument/2006/relationships" xmlns:p="http://schemas.openxmlformats.org/presentationml/2006/main">
+  <p:cSld>
+    <p:spTree>
+      <p:nvGrpSpPr>
+        <p:cNvPr id="1" name=""/>
+        <p:cNvGrpSpPr/>
+        <p:nvPr/>
+      </p:nvGrpSpPr>
+      <p:grpSpPr>
+        <a:xfrm>
+          <a:off x="0" y="0"/>
+          <a:ext cx="0" cy="0"/>
+          <a:chOff x="0" y="0"/>
+          <a:chExt cx="0" cy="0"/>
+        </a:xfrm>
+      </p:grpSpPr>
+      <p:sp>
+        <p:nvSpPr>
+          <p:cNvPr id="2" name="Slide Image Placeholder 1"/>
+          <p:cNvSpPr>
+            <a:spLocks noGrp="1" noRot="1" noChangeAspect="1"/>
+          </p:cNvSpPr>
+          <p:nvPr>
+            <p:ph type="sldImg"/>
+          </p:nvPr>
+        </p:nvSpPr>
+        <p:spPr/>
+      </p:sp>
+      <p:sp>
+        <p:nvSpPr>
+          <p:cNvPr id="3" name="Notes Placeholder 2"/>
+          <p:cNvSpPr>
+            <a:spLocks noGrp="1"/>
+          </p:cNvSpPr>
+          <p:nvPr>
+            <p:ph type="body" idx="1"/>
+          </p:nvPr>
+        </p:nvSpPr>
+        <p:spPr/>
+        <p:txBody>
+          <a:bodyPr/>
+          <a:lstStyle/>
+          <a:p>
+            <a:endParaRPr lang="en-US" dirty="0"/>
+          </a:p>
+        </p:txBody>
+      </p:sp>
+      <p:sp>
+        <p:nvSpPr>
+          <p:cNvPr id="4" name="Slide Number Placeholder 3"/>
+          <p:cNvSpPr>
+            <a:spLocks noGrp="1"/>
+          </p:cNvSpPr>
+          <p:nvPr>
+            <p:ph type="sldNum" sz="quarter" idx="10"/>
+          </p:nvPr>
+        </p:nvSpPr>
+        <p:spPr/>
+        <p:txBody>
+          <a:bodyPr/>
+          <a:lstStyle/>
+          <a:p>
+            <a:fld id="{F7021451-1387-4CA6-816F-3879F97B5CBC}" type="slidenum">
+              <a:rPr lang="en-US"/>
+              <a:t>17</a:t>
+            </a:fld>
+            <a:endParaRPr lang="en-US"/>
+          </a:p>
+        </p:txBody>
+      </p:sp>
+    </p:spTree>
+    <p:extLst>
+      <p:ext uri="{BB962C8B-B14F-4D97-AF65-F5344CB8AC3E}">
+        <p14:creationId xmlns:p14="http://schemas.microsoft.com/office/powerpoint/2010/main" val="1024086991"/>
+      </p:ext>
+    </p:extLst>
+  </p:cSld>
+  <p:clrMapOvr>
+    <a:masterClrMapping/>
+  </p:clrMapOvr>
+</p:notes>
+</file>
+
+<file path=ppt/notesSlides/notesSlide18.xml><?xml version="1.0" encoding="utf-8"?>
+<p:notes xmlns:a="http://schemas.openxmlformats.org/drawingml/2006/main" xmlns:r="http://schemas.openxmlformats.org/officeDocument/2006/relationships" xmlns:p="http://schemas.openxmlformats.org/presentationml/2006/main">
+  <p:cSld>
+    <p:spTree>
+      <p:nvGrpSpPr>
+        <p:cNvPr id="1" name="">
+          <a:extLst>
+            <a:ext uri="{FF2B5EF4-FFF2-40B4-BE49-F238E27FC236}">
+              <a16:creationId xmlns:a16="http://schemas.microsoft.com/office/drawing/2014/main" id="{EF4CE19E-3C5E-CF86-5B62-A3524CFFEDF6}"/>
+            </a:ext>
+          </a:extLst>
+        </p:cNvPr>
+        <p:cNvGrpSpPr/>
+        <p:nvPr/>
+      </p:nvGrpSpPr>
+      <p:grpSpPr>
+        <a:xfrm>
+          <a:off x="0" y="0"/>
+          <a:ext cx="0" cy="0"/>
+          <a:chOff x="0" y="0"/>
+          <a:chExt cx="0" cy="0"/>
+        </a:xfrm>
+      </p:grpSpPr>
+      <p:sp>
+        <p:nvSpPr>
+          <p:cNvPr id="2" name="Slide Image Placeholder 1">
+            <a:extLst>
+              <a:ext uri="{FF2B5EF4-FFF2-40B4-BE49-F238E27FC236}">
+                <a16:creationId xmlns:a16="http://schemas.microsoft.com/office/drawing/2014/main" id="{603BC15A-9CA4-F613-86F4-6FA2813D102B}"/>
+              </a:ext>
+            </a:extLst>
+          </p:cNvPr>
+          <p:cNvSpPr>
+            <a:spLocks noGrp="1" noRot="1" noChangeAspect="1"/>
+          </p:cNvSpPr>
+          <p:nvPr>
+            <p:ph type="sldImg"/>
+          </p:nvPr>
+        </p:nvSpPr>
+        <p:spPr/>
+      </p:sp>
+      <p:sp>
+        <p:nvSpPr>
+          <p:cNvPr id="3" name="Notes Placeholder 2">
+            <a:extLst>
+              <a:ext uri="{FF2B5EF4-FFF2-40B4-BE49-F238E27FC236}">
+                <a16:creationId xmlns:a16="http://schemas.microsoft.com/office/drawing/2014/main" id="{AF96DBF4-FACD-FA1E-97C5-86615741FC12}"/>
+              </a:ext>
+            </a:extLst>
+          </p:cNvPr>
+          <p:cNvSpPr>
+            <a:spLocks noGrp="1"/>
+          </p:cNvSpPr>
+          <p:nvPr>
+            <p:ph type="body" idx="1"/>
+          </p:nvPr>
+        </p:nvSpPr>
+        <p:spPr/>
+        <p:txBody>
+          <a:bodyPr/>
+          <a:lstStyle/>
+          <a:p>
+            <a:endParaRPr lang="en-US" dirty="0"/>
+          </a:p>
+        </p:txBody>
+      </p:sp>
+      <p:sp>
+        <p:nvSpPr>
+          <p:cNvPr id="4" name="Slide Number Placeholder 3">
+            <a:extLst>
+              <a:ext uri="{FF2B5EF4-FFF2-40B4-BE49-F238E27FC236}">
+                <a16:creationId xmlns:a16="http://schemas.microsoft.com/office/drawing/2014/main" id="{177BF0EF-0846-3037-D4A1-D04F9EE98D9B}"/>
+              </a:ext>
+            </a:extLst>
+          </p:cNvPr>
+          <p:cNvSpPr>
+            <a:spLocks noGrp="1"/>
+          </p:cNvSpPr>
+          <p:nvPr>
+            <p:ph type="sldNum" sz="quarter" idx="10"/>
+          </p:nvPr>
+        </p:nvSpPr>
+        <p:spPr/>
+        <p:txBody>
+          <a:bodyPr/>
+          <a:lstStyle/>
+          <a:p>
+            <a:fld id="{F7021451-1387-4CA6-816F-3879F97B5CBC}" type="slidenum">
+              <a:rPr lang="en-US"/>
+              <a:t>18</a:t>
+            </a:fld>
+            <a:endParaRPr lang="en-US"/>
+          </a:p>
+        </p:txBody>
+      </p:sp>
+    </p:spTree>
+    <p:extLst>
+      <p:ext uri="{BB962C8B-B14F-4D97-AF65-F5344CB8AC3E}">
+        <p14:creationId xmlns:p14="http://schemas.microsoft.com/office/powerpoint/2010/main" val="2065432649"/>
+      </p:ext>
+    </p:extLst>
+  </p:cSld>
+  <p:clrMapOvr>
+    <a:masterClrMapping/>
+  </p:clrMapOvr>
+</p:notes>
+</file>
+
+<file path=ppt/notesSlides/notesSlide19.xml><?xml version="1.0" encoding="utf-8"?>
+<p:notes xmlns:a="http://schemas.openxmlformats.org/drawingml/2006/main" xmlns:r="http://schemas.openxmlformats.org/officeDocument/2006/relationships" xmlns:p="http://schemas.openxmlformats.org/presentationml/2006/main">
+  <p:cSld>
+    <p:spTree>
+      <p:nvGrpSpPr>
+        <p:cNvPr id="1" name="">
+          <a:extLst>
+            <a:ext uri="{FF2B5EF4-FFF2-40B4-BE49-F238E27FC236}">
+              <a16:creationId xmlns:a16="http://schemas.microsoft.com/office/drawing/2014/main" id="{ED810624-6881-37C3-2787-4F7979B63BFE}"/>
+            </a:ext>
+          </a:extLst>
+        </p:cNvPr>
+        <p:cNvGrpSpPr/>
+        <p:nvPr/>
+      </p:nvGrpSpPr>
+      <p:grpSpPr>
+        <a:xfrm>
+          <a:off x="0" y="0"/>
+          <a:ext cx="0" cy="0"/>
+          <a:chOff x="0" y="0"/>
+          <a:chExt cx="0" cy="0"/>
+        </a:xfrm>
+      </p:grpSpPr>
+      <p:sp>
+        <p:nvSpPr>
+          <p:cNvPr id="2" name="Slide Image Placeholder 1">
+            <a:extLst>
+              <a:ext uri="{FF2B5EF4-FFF2-40B4-BE49-F238E27FC236}">
+                <a16:creationId xmlns:a16="http://schemas.microsoft.com/office/drawing/2014/main" id="{40CE2C56-B9F9-96AB-9D42-3FD826A85361}"/>
+              </a:ext>
+            </a:extLst>
+          </p:cNvPr>
+          <p:cNvSpPr>
+            <a:spLocks noGrp="1" noRot="1" noChangeAspect="1"/>
+          </p:cNvSpPr>
+          <p:nvPr>
+            <p:ph type="sldImg"/>
+          </p:nvPr>
+        </p:nvSpPr>
+        <p:spPr/>
+      </p:sp>
+      <p:sp>
+        <p:nvSpPr>
+          <p:cNvPr id="3" name="Notes Placeholder 2">
+            <a:extLst>
+              <a:ext uri="{FF2B5EF4-FFF2-40B4-BE49-F238E27FC236}">
+                <a16:creationId xmlns:a16="http://schemas.microsoft.com/office/drawing/2014/main" id="{D0D7004D-AE16-427E-2A98-BD512B804BC1}"/>
+              </a:ext>
+            </a:extLst>
+          </p:cNvPr>
+          <p:cNvSpPr>
+            <a:spLocks noGrp="1"/>
+          </p:cNvSpPr>
+          <p:nvPr>
+            <p:ph type="body" idx="1"/>
+          </p:nvPr>
+        </p:nvSpPr>
+        <p:spPr/>
+        <p:txBody>
+          <a:bodyPr/>
+          <a:lstStyle/>
+          <a:p>
+            <a:endParaRPr lang="en-US" dirty="0"/>
+          </a:p>
+        </p:txBody>
+      </p:sp>
+      <p:sp>
+        <p:nvSpPr>
+          <p:cNvPr id="4" name="Slide Number Placeholder 3">
+            <a:extLst>
+              <a:ext uri="{FF2B5EF4-FFF2-40B4-BE49-F238E27FC236}">
+                <a16:creationId xmlns:a16="http://schemas.microsoft.com/office/drawing/2014/main" id="{EC17A28D-D0FE-5A5E-2E73-93CD04614FC1}"/>
+              </a:ext>
+            </a:extLst>
+          </p:cNvPr>
+          <p:cNvSpPr>
+            <a:spLocks noGrp="1"/>
+          </p:cNvSpPr>
+          <p:nvPr>
+            <p:ph type="sldNum" sz="quarter" idx="10"/>
+          </p:nvPr>
+        </p:nvSpPr>
+        <p:spPr/>
+        <p:txBody>
+          <a:bodyPr/>
+          <a:lstStyle/>
+          <a:p>
+            <a:fld id="{F7021451-1387-4CA6-816F-3879F97B5CBC}" type="slidenum">
+              <a:rPr lang="en-US"/>
+              <a:t>19</a:t>
+            </a:fld>
+            <a:endParaRPr lang="en-US"/>
+          </a:p>
+        </p:txBody>
+      </p:sp>
+    </p:spTree>
+    <p:extLst>
+      <p:ext uri="{BB962C8B-B14F-4D97-AF65-F5344CB8AC3E}">
+        <p14:creationId xmlns:p14="http://schemas.microsoft.com/office/powerpoint/2010/main" val="793139673"/>
+      </p:ext>
+    </p:extLst>
+  </p:cSld>
+  <p:clrMapOvr>
+    <a:masterClrMapping/>
+  </p:clrMapOvr>
+</p:notes>
+</file>
+
 <file path=ppt/notesSlides/notesSlide2.xml><?xml version="1.0" encoding="utf-8"?>
 <p:notes xmlns:a="http://schemas.openxmlformats.org/drawingml/2006/main" xmlns:r="http://schemas.openxmlformats.org/officeDocument/2006/relationships" xmlns:p="http://schemas.openxmlformats.org/presentationml/2006/main">
   <p:cSld>
@@ -1456,7 +1868,13 @@
   <p:cSld>
     <p:spTree>
       <p:nvGrpSpPr>
-        <p:cNvPr id="1" name=""/>
+        <p:cNvPr id="1" name="">
+          <a:extLst>
+            <a:ext uri="{FF2B5EF4-FFF2-40B4-BE49-F238E27FC236}">
+              <a16:creationId xmlns:a16="http://schemas.microsoft.com/office/drawing/2014/main" id="{DC4A25AE-60C7-CC0D-3EAE-54B855C27B37}"/>
+            </a:ext>
+          </a:extLst>
+        </p:cNvPr>
         <p:cNvGrpSpPr/>
         <p:nvPr/>
       </p:nvGrpSpPr>
@@ -1470,7 +1888,13 @@
       </p:grpSpPr>
       <p:sp>
         <p:nvSpPr>
-          <p:cNvPr id="2" name="Slide Image Placeholder 1"/>
+          <p:cNvPr id="2" name="Slide Image Placeholder 1">
+            <a:extLst>
+              <a:ext uri="{FF2B5EF4-FFF2-40B4-BE49-F238E27FC236}">
+                <a16:creationId xmlns:a16="http://schemas.microsoft.com/office/drawing/2014/main" id="{1D5E1D51-B18A-7338-CE75-85E86405FADA}"/>
+              </a:ext>
+            </a:extLst>
+          </p:cNvPr>
           <p:cNvSpPr>
             <a:spLocks noGrp="1" noRot="1" noChangeAspect="1"/>
           </p:cNvSpPr>
@@ -1482,7 +1906,13 @@
       </p:sp>
       <p:sp>
         <p:nvSpPr>
-          <p:cNvPr id="3" name="Notes Placeholder 2"/>
+          <p:cNvPr id="3" name="Notes Placeholder 2">
+            <a:extLst>
+              <a:ext uri="{FF2B5EF4-FFF2-40B4-BE49-F238E27FC236}">
+                <a16:creationId xmlns:a16="http://schemas.microsoft.com/office/drawing/2014/main" id="{E56DDF9D-DCCB-1D6D-E546-BF76CA5AB136}"/>
+              </a:ext>
+            </a:extLst>
+          </p:cNvPr>
           <p:cNvSpPr>
             <a:spLocks noGrp="1"/>
           </p:cNvSpPr>
@@ -1501,7 +1931,13 @@
       </p:sp>
       <p:sp>
         <p:nvSpPr>
-          <p:cNvPr id="4" name="Slide Number Placeholder 3"/>
+          <p:cNvPr id="4" name="Slide Number Placeholder 3">
+            <a:extLst>
+              <a:ext uri="{FF2B5EF4-FFF2-40B4-BE49-F238E27FC236}">
+                <a16:creationId xmlns:a16="http://schemas.microsoft.com/office/drawing/2014/main" id="{E9F667EE-7432-5A5E-3024-7ACEC766E992}"/>
+              </a:ext>
+            </a:extLst>
+          </p:cNvPr>
           <p:cNvSpPr>
             <a:spLocks noGrp="1"/>
           </p:cNvSpPr>
@@ -1525,7 +1961,7 @@
     </p:spTree>
     <p:extLst>
       <p:ext uri="{BB962C8B-B14F-4D97-AF65-F5344CB8AC3E}">
-        <p14:creationId xmlns:p14="http://schemas.microsoft.com/office/powerpoint/2010/main" val="1024086991"/>
+        <p14:creationId xmlns:p14="http://schemas.microsoft.com/office/powerpoint/2010/main" val="715808442"/>
       </p:ext>
     </p:extLst>
   </p:cSld>
@@ -2564,6 +3000,1258 @@
 
 <file path=ppt/slides/slide10.xml><?xml version="1.0" encoding="utf-8"?>
 <p:sld xmlns:a="http://schemas.openxmlformats.org/drawingml/2006/main" xmlns:r="http://schemas.openxmlformats.org/officeDocument/2006/relationships" xmlns:p="http://schemas.openxmlformats.org/presentationml/2006/main">
+  <p:cSld>
+    <p:spTree>
+      <p:nvGrpSpPr>
+        <p:cNvPr id="1" name="">
+          <a:extLst>
+            <a:ext uri="{FF2B5EF4-FFF2-40B4-BE49-F238E27FC236}">
+              <a16:creationId xmlns:a16="http://schemas.microsoft.com/office/drawing/2014/main" id="{9D928754-DB95-B8D5-F4B6-4A81DAA41B76}"/>
+            </a:ext>
+          </a:extLst>
+        </p:cNvPr>
+        <p:cNvGrpSpPr/>
+        <p:nvPr/>
+      </p:nvGrpSpPr>
+      <p:grpSpPr>
+        <a:xfrm>
+          <a:off x="0" y="0"/>
+          <a:ext cx="0" cy="0"/>
+          <a:chOff x="0" y="0"/>
+          <a:chExt cx="0" cy="0"/>
+        </a:xfrm>
+      </p:grpSpPr>
+      <p:sp>
+        <p:nvSpPr>
+          <p:cNvPr id="2" name="Shape 0">
+            <a:extLst>
+              <a:ext uri="{FF2B5EF4-FFF2-40B4-BE49-F238E27FC236}">
+                <a16:creationId xmlns:a16="http://schemas.microsoft.com/office/drawing/2014/main" id="{C53F4E6D-FCA9-6781-9BED-B80ABB56DE06}"/>
+              </a:ext>
+            </a:extLst>
+          </p:cNvPr>
+          <p:cNvSpPr/>
+          <p:nvPr/>
+        </p:nvSpPr>
+        <p:spPr>
+          <a:xfrm>
+            <a:off x="0" y="0"/>
+            <a:ext cx="12192000" cy="6858000"/>
+          </a:xfrm>
+          <a:prstGeom prst="rect">
+            <a:avLst/>
+          </a:prstGeom>
+          <a:solidFill>
+            <a:srgbClr val="FFFFFF"/>
+          </a:solidFill>
+          <a:ln/>
+        </p:spPr>
+        <p:txBody>
+          <a:bodyPr/>
+          <a:lstStyle/>
+          <a:p>
+            <a:endParaRPr lang="en-US"/>
+          </a:p>
+        </p:txBody>
+      </p:sp>
+      <p:sp>
+        <p:nvSpPr>
+          <p:cNvPr id="3" name="Text 1">
+            <a:extLst>
+              <a:ext uri="{FF2B5EF4-FFF2-40B4-BE49-F238E27FC236}">
+                <a16:creationId xmlns:a16="http://schemas.microsoft.com/office/drawing/2014/main" id="{7A793B47-B503-933B-66DD-B748EDB16C9E}"/>
+              </a:ext>
+            </a:extLst>
+          </p:cNvPr>
+          <p:cNvSpPr/>
+          <p:nvPr/>
+        </p:nvSpPr>
+        <p:spPr>
+          <a:xfrm>
+            <a:off x="762000" y="837977"/>
+            <a:ext cx="1218084" cy="261937"/>
+          </a:xfrm>
+          <a:prstGeom prst="rect">
+            <a:avLst/>
+          </a:prstGeom>
+          <a:noFill/>
+          <a:ln/>
+        </p:spPr>
+        <p:txBody>
+          <a:bodyPr wrap="square" lIns="0" tIns="0" rIns="0" bIns="0" rtlCol="0" anchor="t">
+            <a:normAutofit lnSpcReduction="10000"/>
+          </a:bodyPr>
+          <a:lstStyle/>
+          <a:p>
+            <a:pPr marL="0" indent="0" algn="l">
+              <a:lnSpc>
+                <a:spcPct val="150000"/>
+              </a:lnSpc>
+              <a:buNone/>
+            </a:pPr>
+            <a:r>
+              <a:rPr lang="en-US" sz="1350" kern="0" spc="189" dirty="0">
+                <a:solidFill>
+                  <a:srgbClr val="800000"/>
+                </a:solidFill>
+                <a:latin typeface="IBM Plex Mono" pitchFamily="34" charset="0"/>
+                <a:ea typeface="IBM Plex Mono" pitchFamily="34" charset="-122"/>
+                <a:cs typeface="IBM Plex Mono" pitchFamily="34" charset="-120"/>
+              </a:rPr>
+              <a:t>MODULE 1B</a:t>
+            </a:r>
+            <a:endParaRPr lang="en-US" sz="1350" dirty="0"/>
+          </a:p>
+        </p:txBody>
+      </p:sp>
+      <p:sp>
+        <p:nvSpPr>
+          <p:cNvPr id="4" name="Text 2">
+            <a:extLst>
+              <a:ext uri="{FF2B5EF4-FFF2-40B4-BE49-F238E27FC236}">
+                <a16:creationId xmlns:a16="http://schemas.microsoft.com/office/drawing/2014/main" id="{35461C7F-8B4C-FFFB-60AE-4F6DB3EA89C4}"/>
+              </a:ext>
+            </a:extLst>
+          </p:cNvPr>
+          <p:cNvSpPr/>
+          <p:nvPr/>
+        </p:nvSpPr>
+        <p:spPr>
+          <a:xfrm>
+            <a:off x="2018184" y="823689"/>
+            <a:ext cx="1218084" cy="295275"/>
+          </a:xfrm>
+          <a:prstGeom prst="rect">
+            <a:avLst/>
+          </a:prstGeom>
+          <a:noFill/>
+          <a:ln/>
+        </p:spPr>
+        <p:txBody>
+          <a:bodyPr wrap="square" lIns="25400" tIns="25400" rIns="25400" bIns="25400" rtlCol="0" anchor="t">
+            <a:normAutofit fontScale="92500" lnSpcReduction="10000"/>
+          </a:bodyPr>
+          <a:lstStyle/>
+          <a:p>
+            <a:pPr marL="0" indent="0" algn="l">
+              <a:lnSpc>
+                <a:spcPct val="150000"/>
+              </a:lnSpc>
+              <a:buNone/>
+            </a:pPr>
+            <a:r>
+              <a:rPr lang="en-US" sz="1350" kern="0" spc="189" dirty="0">
+                <a:solidFill>
+                  <a:srgbClr val="B07A00"/>
+                </a:solidFill>
+                <a:latin typeface="IBM Plex Mono" pitchFamily="34" charset="0"/>
+                <a:ea typeface="IBM Plex Mono" pitchFamily="34" charset="-122"/>
+                <a:cs typeface="IBM Plex Mono" pitchFamily="34" charset="-120"/>
+              </a:rPr>
+              <a:t>/ RESULTS</a:t>
+            </a:r>
+            <a:endParaRPr lang="en-US" sz="1350" dirty="0"/>
+          </a:p>
+        </p:txBody>
+      </p:sp>
+      <p:sp>
+        <p:nvSpPr>
+          <p:cNvPr id="5" name="Shape 3">
+            <a:extLst>
+              <a:ext uri="{FF2B5EF4-FFF2-40B4-BE49-F238E27FC236}">
+                <a16:creationId xmlns:a16="http://schemas.microsoft.com/office/drawing/2014/main" id="{29184C4C-9092-92F7-C6C8-139BCE2CFD13}"/>
+              </a:ext>
+            </a:extLst>
+          </p:cNvPr>
+          <p:cNvSpPr/>
+          <p:nvPr/>
+        </p:nvSpPr>
+        <p:spPr>
+          <a:xfrm>
+            <a:off x="762000" y="1290414"/>
+            <a:ext cx="457200" cy="28575"/>
+          </a:xfrm>
+          <a:prstGeom prst="roundRect">
+            <a:avLst>
+              <a:gd name="adj" fmla="val 50000"/>
+            </a:avLst>
+          </a:prstGeom>
+          <a:solidFill>
+            <a:srgbClr val="800000"/>
+          </a:solidFill>
+          <a:ln/>
+        </p:spPr>
+        <p:txBody>
+          <a:bodyPr/>
+          <a:lstStyle/>
+          <a:p>
+            <a:endParaRPr lang="en-US"/>
+          </a:p>
+        </p:txBody>
+      </p:sp>
+      <p:sp>
+        <p:nvSpPr>
+          <p:cNvPr id="6" name="Text 4">
+            <a:extLst>
+              <a:ext uri="{FF2B5EF4-FFF2-40B4-BE49-F238E27FC236}">
+                <a16:creationId xmlns:a16="http://schemas.microsoft.com/office/drawing/2014/main" id="{D912D5B3-EA91-6DDC-F448-0A6EFED6DA22}"/>
+              </a:ext>
+            </a:extLst>
+          </p:cNvPr>
+          <p:cNvSpPr/>
+          <p:nvPr/>
+        </p:nvSpPr>
+        <p:spPr>
+          <a:xfrm>
+            <a:off x="762000" y="1528539"/>
+            <a:ext cx="4225137" cy="1457697"/>
+          </a:xfrm>
+          <a:prstGeom prst="rect">
+            <a:avLst/>
+          </a:prstGeom>
+          <a:noFill/>
+          <a:ln/>
+        </p:spPr>
+        <p:txBody>
+          <a:bodyPr wrap="square" lIns="25400" tIns="25400" rIns="25400" bIns="25400" rtlCol="0" anchor="t">
+            <a:normAutofit fontScale="92500" lnSpcReduction="20000"/>
+          </a:bodyPr>
+          <a:lstStyle/>
+          <a:p>
+            <a:pPr marL="0" indent="0" algn="l">
+              <a:lnSpc>
+                <a:spcPct val="108000"/>
+              </a:lnSpc>
+              <a:buNone/>
+            </a:pPr>
+            <a:r>
+              <a:rPr lang="en-US" sz="3450" b="1" kern="0" spc="-69" dirty="0">
+                <a:solidFill>
+                  <a:srgbClr val="1A1714"/>
+                </a:solidFill>
+                <a:latin typeface="Arial" pitchFamily="34" charset="0"/>
+                <a:ea typeface="Arial" pitchFamily="34" charset="-122"/>
+                <a:cs typeface="Arial" pitchFamily="34" charset="-120"/>
+              </a:rPr>
+              <a:t>Composition features → Model ladder → SHAP</a:t>
+            </a:r>
+            <a:endParaRPr lang="en-US" sz="3450" dirty="0"/>
+          </a:p>
+        </p:txBody>
+      </p:sp>
+      <p:sp>
+        <p:nvSpPr>
+          <p:cNvPr id="7" name="Text 5">
+            <a:extLst>
+              <a:ext uri="{FF2B5EF4-FFF2-40B4-BE49-F238E27FC236}">
+                <a16:creationId xmlns:a16="http://schemas.microsoft.com/office/drawing/2014/main" id="{83C8AF1C-26BE-576B-6080-D88CE3770767}"/>
+              </a:ext>
+            </a:extLst>
+          </p:cNvPr>
+          <p:cNvSpPr/>
+          <p:nvPr/>
+        </p:nvSpPr>
+        <p:spPr>
+          <a:xfrm>
+            <a:off x="762000" y="3214836"/>
+            <a:ext cx="2173932" cy="280988"/>
+          </a:xfrm>
+          <a:prstGeom prst="rect">
+            <a:avLst/>
+          </a:prstGeom>
+          <a:noFill/>
+          <a:ln/>
+        </p:spPr>
+        <p:txBody>
+          <a:bodyPr wrap="square" lIns="25400" tIns="25400" rIns="25400" bIns="25400" rtlCol="0" anchor="t">
+            <a:normAutofit fontScale="92500" lnSpcReduction="20000"/>
+          </a:bodyPr>
+          <a:lstStyle/>
+          <a:p>
+            <a:pPr marL="0" indent="0" algn="l">
+              <a:lnSpc>
+                <a:spcPct val="150000"/>
+              </a:lnSpc>
+              <a:buNone/>
+            </a:pPr>
+            <a:r>
+              <a:rPr lang="en-US" sz="1275" kern="0" spc="127" dirty="0">
+                <a:solidFill>
+                  <a:srgbClr val="6E665E"/>
+                </a:solidFill>
+                <a:latin typeface="IBM Plex Mono" pitchFamily="34" charset="0"/>
+                <a:ea typeface="IBM Plex Mono" pitchFamily="34" charset="-122"/>
+                <a:cs typeface="IBM Plex Mono" pitchFamily="34" charset="-120"/>
+              </a:rPr>
+              <a:t>R²</a:t>
+            </a:r>
+            <a:endParaRPr lang="en-US" sz="1275" dirty="0"/>
+          </a:p>
+        </p:txBody>
+      </p:sp>
+      <p:sp>
+        <p:nvSpPr>
+          <p:cNvPr id="8" name="Text 6">
+            <a:extLst>
+              <a:ext uri="{FF2B5EF4-FFF2-40B4-BE49-F238E27FC236}">
+                <a16:creationId xmlns:a16="http://schemas.microsoft.com/office/drawing/2014/main" id="{C68E59C7-BB07-6B9B-3A82-CFAFD3DA9A59}"/>
+              </a:ext>
+            </a:extLst>
+          </p:cNvPr>
+          <p:cNvSpPr/>
+          <p:nvPr/>
+        </p:nvSpPr>
+        <p:spPr>
+          <a:xfrm>
+            <a:off x="762000" y="3552974"/>
+            <a:ext cx="2173932" cy="742950"/>
+          </a:xfrm>
+          <a:prstGeom prst="rect">
+            <a:avLst/>
+          </a:prstGeom>
+          <a:noFill/>
+          <a:ln/>
+        </p:spPr>
+        <p:txBody>
+          <a:bodyPr wrap="square" lIns="25400" tIns="25400" rIns="25400" bIns="25400" rtlCol="0" anchor="t">
+            <a:normAutofit fontScale="70000" lnSpcReduction="20000"/>
+          </a:bodyPr>
+          <a:lstStyle/>
+          <a:p>
+            <a:pPr marL="0" indent="0" algn="l">
+              <a:lnSpc>
+                <a:spcPct val="100000"/>
+              </a:lnSpc>
+              <a:buNone/>
+            </a:pPr>
+            <a:r>
+              <a:rPr lang="en-US" sz="5550" b="1" kern="0" spc="-111" dirty="0">
+                <a:solidFill>
+                  <a:srgbClr val="1A1714"/>
+                </a:solidFill>
+                <a:latin typeface="Arial" pitchFamily="34" charset="0"/>
+                <a:ea typeface="Arial" pitchFamily="34" charset="-122"/>
+                <a:cs typeface="Arial" pitchFamily="34" charset="-120"/>
+              </a:rPr>
+              <a:t>0.86–0.98</a:t>
+            </a:r>
+            <a:endParaRPr lang="en-US" sz="5550" dirty="0"/>
+          </a:p>
+        </p:txBody>
+      </p:sp>
+      <p:sp>
+        <p:nvSpPr>
+          <p:cNvPr id="9" name="Text 7">
+            <a:extLst>
+              <a:ext uri="{FF2B5EF4-FFF2-40B4-BE49-F238E27FC236}">
+                <a16:creationId xmlns:a16="http://schemas.microsoft.com/office/drawing/2014/main" id="{34D6A6C9-A427-6432-3DA4-5C5808CAE032}"/>
+              </a:ext>
+            </a:extLst>
+          </p:cNvPr>
+          <p:cNvSpPr/>
+          <p:nvPr/>
+        </p:nvSpPr>
+        <p:spPr>
+          <a:xfrm>
+            <a:off x="761999" y="4353074"/>
+            <a:ext cx="3599794" cy="1538140"/>
+          </a:xfrm>
+          <a:prstGeom prst="rect">
+            <a:avLst/>
+          </a:prstGeom>
+          <a:noFill/>
+          <a:ln/>
+        </p:spPr>
+        <p:txBody>
+          <a:bodyPr wrap="square" lIns="25400" tIns="25400" rIns="25400" bIns="25400" rtlCol="0" anchor="t">
+            <a:normAutofit fontScale="92500" lnSpcReduction="20000"/>
+          </a:bodyPr>
+          <a:lstStyle/>
+          <a:p>
+            <a:pPr marL="0" indent="0" algn="l">
+              <a:lnSpc>
+                <a:spcPct val="150000"/>
+              </a:lnSpc>
+              <a:buNone/>
+            </a:pPr>
+            <a:r>
+              <a:rPr lang="en-US" sz="1600" dirty="0">
+                <a:solidFill>
+                  <a:srgbClr val="6E665E"/>
+                </a:solidFill>
+                <a:latin typeface="Arial" pitchFamily="34" charset="0"/>
+                <a:ea typeface="Arial" pitchFamily="34" charset="-122"/>
+                <a:cs typeface="Arial" pitchFamily="34" charset="-120"/>
+              </a:rPr>
+              <a:t>Steels</a:t>
+            </a:r>
+          </a:p>
+          <a:p>
+            <a:pPr marL="0" indent="0" algn="l">
+              <a:lnSpc>
+                <a:spcPct val="150000"/>
+              </a:lnSpc>
+              <a:buNone/>
+            </a:pPr>
+            <a:r>
+              <a:rPr lang="en-US" sz="1600" dirty="0">
+                <a:solidFill>
+                  <a:srgbClr val="6E665E"/>
+                </a:solidFill>
+                <a:latin typeface="Arial" pitchFamily="34" charset="0"/>
+                <a:ea typeface="Arial" pitchFamily="34" charset="-122"/>
+                <a:cs typeface="Arial" pitchFamily="34" charset="-120"/>
+              </a:rPr>
+              <a:t>MAX-phase ceramics </a:t>
+            </a:r>
+          </a:p>
+          <a:p>
+            <a:pPr marL="0" indent="0" algn="l">
+              <a:lnSpc>
+                <a:spcPct val="150000"/>
+              </a:lnSpc>
+              <a:buNone/>
+            </a:pPr>
+            <a:r>
+              <a:rPr lang="en-US" sz="1600" dirty="0">
+                <a:solidFill>
+                  <a:srgbClr val="6E665E"/>
+                </a:solidFill>
+                <a:latin typeface="Arial" pitchFamily="34" charset="0"/>
+                <a:ea typeface="Arial" pitchFamily="34" charset="-122"/>
+                <a:cs typeface="Arial" pitchFamily="34" charset="-120"/>
+              </a:rPr>
+              <a:t>Double perovskites (PV) </a:t>
+            </a:r>
+          </a:p>
+          <a:p>
+            <a:pPr marL="0" indent="0" algn="l">
+              <a:lnSpc>
+                <a:spcPct val="150000"/>
+              </a:lnSpc>
+              <a:buNone/>
+            </a:pPr>
+            <a:r>
+              <a:rPr lang="en-US" sz="1600" dirty="0">
+                <a:solidFill>
+                  <a:srgbClr val="6E665E"/>
+                </a:solidFill>
+                <a:latin typeface="Arial" pitchFamily="34" charset="0"/>
+                <a:ea typeface="Arial" pitchFamily="34" charset="-122"/>
+                <a:cs typeface="Arial" pitchFamily="34" charset="-120"/>
+              </a:rPr>
+              <a:t>Heusler magnets </a:t>
+            </a:r>
+          </a:p>
+          <a:p>
+            <a:pPr marL="0" indent="0" algn="l">
+              <a:lnSpc>
+                <a:spcPct val="150000"/>
+              </a:lnSpc>
+              <a:buNone/>
+            </a:pPr>
+            <a:r>
+              <a:rPr lang="en-US" sz="1600" dirty="0">
+                <a:solidFill>
+                  <a:srgbClr val="6E665E"/>
+                </a:solidFill>
+                <a:latin typeface="Arial" pitchFamily="34" charset="0"/>
+                <a:ea typeface="Arial" pitchFamily="34" charset="-122"/>
+                <a:cs typeface="Arial" pitchFamily="34" charset="-120"/>
+              </a:rPr>
+              <a:t>Formation enthalpy</a:t>
+            </a:r>
+            <a:endParaRPr lang="en-US" sz="1600" dirty="0"/>
+          </a:p>
+        </p:txBody>
+      </p:sp>
+      <p:sp>
+        <p:nvSpPr>
+          <p:cNvPr id="11" name="Shape 9">
+            <a:extLst>
+              <a:ext uri="{FF2B5EF4-FFF2-40B4-BE49-F238E27FC236}">
+                <a16:creationId xmlns:a16="http://schemas.microsoft.com/office/drawing/2014/main" id="{A6FF12D6-56E2-2153-6850-E1C5CD3AFFF7}"/>
+              </a:ext>
+            </a:extLst>
+          </p:cNvPr>
+          <p:cNvSpPr/>
+          <p:nvPr/>
+        </p:nvSpPr>
+        <p:spPr>
+          <a:xfrm>
+            <a:off x="5397475" y="1264444"/>
+            <a:ext cx="6032525" cy="4000500"/>
+          </a:xfrm>
+          <a:prstGeom prst="roundRect">
+            <a:avLst>
+              <a:gd name="adj" fmla="val 2857"/>
+            </a:avLst>
+          </a:prstGeom>
+          <a:solidFill>
+            <a:srgbClr val="FFFFFF"/>
+          </a:solidFill>
+          <a:ln w="9525">
+            <a:solidFill>
+              <a:srgbClr val="E8E3DB"/>
+            </a:solidFill>
+            <a:prstDash val="solid"/>
+          </a:ln>
+          <a:effectLst>
+            <a:outerShdw blurRad="114300" dist="38100" dir="5400000" algn="bl" rotWithShape="0">
+              <a:srgbClr val="1A1714">
+                <a:alpha val="8000"/>
+              </a:srgbClr>
+            </a:outerShdw>
+          </a:effectLst>
+        </p:spPr>
+        <p:txBody>
+          <a:bodyPr/>
+          <a:lstStyle/>
+          <a:p>
+            <a:endParaRPr lang="en-US"/>
+          </a:p>
+        </p:txBody>
+      </p:sp>
+      <p:sp>
+        <p:nvSpPr>
+          <p:cNvPr id="15" name="Shape 12">
+            <a:extLst>
+              <a:ext uri="{FF2B5EF4-FFF2-40B4-BE49-F238E27FC236}">
+                <a16:creationId xmlns:a16="http://schemas.microsoft.com/office/drawing/2014/main" id="{5AA4ACBD-9642-F967-1C9F-19319D45854D}"/>
+              </a:ext>
+            </a:extLst>
+          </p:cNvPr>
+          <p:cNvSpPr/>
+          <p:nvPr/>
+        </p:nvSpPr>
+        <p:spPr>
+          <a:xfrm>
+            <a:off x="762000" y="6176963"/>
+            <a:ext cx="10668000" cy="9525"/>
+          </a:xfrm>
+          <a:prstGeom prst="rect">
+            <a:avLst/>
+          </a:prstGeom>
+          <a:solidFill>
+            <a:srgbClr val="E8E3DB"/>
+          </a:solidFill>
+          <a:ln/>
+        </p:spPr>
+        <p:txBody>
+          <a:bodyPr/>
+          <a:lstStyle/>
+          <a:p>
+            <a:endParaRPr lang="en-US"/>
+          </a:p>
+        </p:txBody>
+      </p:sp>
+      <p:sp>
+        <p:nvSpPr>
+          <p:cNvPr id="16" name="Text 13">
+            <a:extLst>
+              <a:ext uri="{FF2B5EF4-FFF2-40B4-BE49-F238E27FC236}">
+                <a16:creationId xmlns:a16="http://schemas.microsoft.com/office/drawing/2014/main" id="{1DBDC999-56BF-6C50-CEFD-B2DC495A8F26}"/>
+              </a:ext>
+            </a:extLst>
+          </p:cNvPr>
+          <p:cNvSpPr/>
+          <p:nvPr/>
+        </p:nvSpPr>
+        <p:spPr>
+          <a:xfrm>
+            <a:off x="762000" y="6319838"/>
+            <a:ext cx="2527995" cy="252413"/>
+          </a:xfrm>
+          <a:prstGeom prst="rect">
+            <a:avLst/>
+          </a:prstGeom>
+          <a:noFill/>
+          <a:ln/>
+        </p:spPr>
+        <p:txBody>
+          <a:bodyPr wrap="square" lIns="25400" tIns="25400" rIns="25400" bIns="25400" rtlCol="0" anchor="t">
+            <a:normAutofit fontScale="92500" lnSpcReduction="10000"/>
+          </a:bodyPr>
+          <a:lstStyle/>
+          <a:p>
+            <a:pPr marL="0" indent="0" algn="l">
+              <a:lnSpc>
+                <a:spcPct val="150000"/>
+              </a:lnSpc>
+              <a:buNone/>
+            </a:pPr>
+            <a:r>
+              <a:rPr lang="en-US" sz="1125" kern="0" spc="68" dirty="0">
+                <a:solidFill>
+                  <a:srgbClr val="800000"/>
+                </a:solidFill>
+                <a:latin typeface="IBM Plex Mono" pitchFamily="34" charset="0"/>
+                <a:ea typeface="IBM Plex Mono" pitchFamily="34" charset="-122"/>
+                <a:cs typeface="IBM Plex Mono" pitchFamily="34" charset="-120"/>
+              </a:rPr>
+              <a:t>UChicago PME · AI Training</a:t>
+            </a:r>
+            <a:endParaRPr lang="en-US" sz="1125" dirty="0"/>
+          </a:p>
+        </p:txBody>
+      </p:sp>
+      <p:sp>
+        <p:nvSpPr>
+          <p:cNvPr id="17" name="Text 14">
+            <a:extLst>
+              <a:ext uri="{FF2B5EF4-FFF2-40B4-BE49-F238E27FC236}">
+                <a16:creationId xmlns:a16="http://schemas.microsoft.com/office/drawing/2014/main" id="{8918062D-D824-2673-0880-747A350B4EE7}"/>
+              </a:ext>
+            </a:extLst>
+          </p:cNvPr>
+          <p:cNvSpPr/>
+          <p:nvPr/>
+        </p:nvSpPr>
+        <p:spPr>
+          <a:xfrm>
+            <a:off x="9449693" y="6319838"/>
+            <a:ext cx="2056507" cy="252413"/>
+          </a:xfrm>
+          <a:prstGeom prst="rect">
+            <a:avLst/>
+          </a:prstGeom>
+          <a:noFill/>
+          <a:ln/>
+        </p:spPr>
+        <p:txBody>
+          <a:bodyPr wrap="square" lIns="25400" tIns="25400" rIns="25400" bIns="25400" rtlCol="0" anchor="t">
+            <a:normAutofit fontScale="70000" lnSpcReduction="20000"/>
+          </a:bodyPr>
+          <a:lstStyle/>
+          <a:p>
+            <a:pPr marL="0" indent="0" algn="l">
+              <a:lnSpc>
+                <a:spcPct val="150000"/>
+              </a:lnSpc>
+              <a:buNone/>
+            </a:pPr>
+            <a:r>
+              <a:rPr lang="en-US" sz="1125" kern="0" spc="68" dirty="0">
+                <a:solidFill>
+                  <a:srgbClr val="938A80"/>
+                </a:solidFill>
+                <a:latin typeface="IBM Plex Mono" pitchFamily="34" charset="0"/>
+                <a:ea typeface="IBM Plex Mono" pitchFamily="34" charset="-122"/>
+                <a:cs typeface="IBM Plex Mono" pitchFamily="34" charset="-120"/>
+              </a:rPr>
+              <a:t>Module 1c — Dataset Gallery</a:t>
+            </a:r>
+            <a:endParaRPr lang="en-US" sz="1125" dirty="0"/>
+          </a:p>
+        </p:txBody>
+      </p:sp>
+      <p:pic>
+        <p:nvPicPr>
+          <p:cNvPr id="13" name="Picture 12">
+            <a:extLst>
+              <a:ext uri="{FF2B5EF4-FFF2-40B4-BE49-F238E27FC236}">
+                <a16:creationId xmlns:a16="http://schemas.microsoft.com/office/drawing/2014/main" id="{20F70D07-2746-B887-40E8-758F0BF78D37}"/>
+              </a:ext>
+            </a:extLst>
+          </p:cNvPr>
+          <p:cNvPicPr>
+            <a:picLocks noChangeAspect="1"/>
+          </p:cNvPicPr>
+          <p:nvPr/>
+        </p:nvPicPr>
+        <p:blipFill>
+          <a:blip r:embed="rId3"/>
+          <a:stretch>
+            <a:fillRect/>
+          </a:stretch>
+        </p:blipFill>
+        <p:spPr>
+          <a:xfrm>
+            <a:off x="5570461" y="1843954"/>
+            <a:ext cx="5774135" cy="2989984"/>
+          </a:xfrm>
+          <a:prstGeom prst="rect">
+            <a:avLst/>
+          </a:prstGeom>
+        </p:spPr>
+      </p:pic>
+    </p:spTree>
+    <p:extLst>
+      <p:ext uri="{BB962C8B-B14F-4D97-AF65-F5344CB8AC3E}">
+        <p14:creationId xmlns:p14="http://schemas.microsoft.com/office/powerpoint/2010/main" val="1763008815"/>
+      </p:ext>
+    </p:extLst>
+  </p:cSld>
+  <p:clrMapOvr>
+    <a:masterClrMapping/>
+  </p:clrMapOvr>
+</p:sld>
+</file>
+
+<file path=ppt/slides/slide11.xml><?xml version="1.0" encoding="utf-8"?>
+<p:sld xmlns:a="http://schemas.openxmlformats.org/drawingml/2006/main" xmlns:r="http://schemas.openxmlformats.org/officeDocument/2006/relationships" xmlns:p="http://schemas.openxmlformats.org/presentationml/2006/main">
+  <p:cSld name="Slide 9">
+    <p:bg>
+      <p:bgPr>
+        <a:solidFill>
+          <a:srgbClr val="1A1714"/>
+        </a:solidFill>
+        <a:effectLst/>
+      </p:bgPr>
+    </p:bg>
+    <p:spTree>
+      <p:nvGrpSpPr>
+        <p:cNvPr id="1" name=""/>
+        <p:cNvGrpSpPr/>
+        <p:nvPr/>
+      </p:nvGrpSpPr>
+      <p:grpSpPr>
+        <a:xfrm>
+          <a:off x="0" y="0"/>
+          <a:ext cx="0" cy="0"/>
+          <a:chOff x="0" y="0"/>
+          <a:chExt cx="0" cy="0"/>
+        </a:xfrm>
+      </p:grpSpPr>
+      <p:sp>
+        <p:nvSpPr>
+          <p:cNvPr id="2" name="Shape 0"/>
+          <p:cNvSpPr/>
+          <p:nvPr/>
+        </p:nvSpPr>
+        <p:spPr>
+          <a:xfrm>
+            <a:off x="0" y="0"/>
+            <a:ext cx="12192000" cy="6858000"/>
+          </a:xfrm>
+          <a:prstGeom prst="rect">
+            <a:avLst/>
+          </a:prstGeom>
+          <a:solidFill>
+            <a:srgbClr val="3D0000"/>
+          </a:solidFill>
+          <a:ln/>
+        </p:spPr>
+        <p:txBody>
+          <a:bodyPr/>
+          <a:lstStyle/>
+          <a:p>
+            <a:endParaRPr lang="en-US"/>
+          </a:p>
+        </p:txBody>
+      </p:sp>
+      <p:sp>
+        <p:nvSpPr>
+          <p:cNvPr id="3" name="Text 1"/>
+          <p:cNvSpPr/>
+          <p:nvPr/>
+        </p:nvSpPr>
+        <p:spPr>
+          <a:xfrm>
+            <a:off x="838200" y="1281931"/>
+            <a:ext cx="1218084" cy="261937"/>
+          </a:xfrm>
+          <a:prstGeom prst="rect">
+            <a:avLst/>
+          </a:prstGeom>
+          <a:noFill/>
+          <a:ln/>
+        </p:spPr>
+        <p:txBody>
+          <a:bodyPr wrap="square" lIns="0" tIns="0" rIns="0" bIns="0" rtlCol="0" anchor="t">
+            <a:normAutofit lnSpcReduction="10000"/>
+          </a:bodyPr>
+          <a:lstStyle/>
+          <a:p>
+            <a:pPr marL="0" indent="0" algn="l">
+              <a:lnSpc>
+                <a:spcPct val="150000"/>
+              </a:lnSpc>
+              <a:buNone/>
+            </a:pPr>
+            <a:r>
+              <a:rPr lang="en-US" sz="1350" kern="0" spc="189" dirty="0">
+                <a:solidFill>
+                  <a:srgbClr val="EAAA00"/>
+                </a:solidFill>
+                <a:latin typeface="IBM Plex Mono" pitchFamily="34" charset="0"/>
+                <a:ea typeface="IBM Plex Mono" pitchFamily="34" charset="-122"/>
+                <a:cs typeface="IBM Plex Mono" pitchFamily="34" charset="-120"/>
+              </a:rPr>
+              <a:t>MODULE 2A</a:t>
+            </a:r>
+            <a:endParaRPr lang="en-US" sz="1350" dirty="0"/>
+          </a:p>
+        </p:txBody>
+      </p:sp>
+      <p:sp>
+        <p:nvSpPr>
+          <p:cNvPr id="4" name="Text 2"/>
+          <p:cNvSpPr/>
+          <p:nvPr/>
+        </p:nvSpPr>
+        <p:spPr>
+          <a:xfrm>
+            <a:off x="2094384" y="1267644"/>
+            <a:ext cx="2106588" cy="295275"/>
+          </a:xfrm>
+          <a:prstGeom prst="rect">
+            <a:avLst/>
+          </a:prstGeom>
+          <a:noFill/>
+          <a:ln/>
+        </p:spPr>
+        <p:txBody>
+          <a:bodyPr wrap="square" lIns="25400" tIns="25400" rIns="25400" bIns="25400" rtlCol="0" anchor="t">
+            <a:normAutofit fontScale="92500" lnSpcReduction="10000"/>
+          </a:bodyPr>
+          <a:lstStyle/>
+          <a:p>
+            <a:pPr marL="0" indent="0" algn="l">
+              <a:lnSpc>
+                <a:spcPct val="150000"/>
+              </a:lnSpc>
+              <a:buNone/>
+            </a:pPr>
+            <a:r>
+              <a:rPr lang="en-US" sz="1350" kern="0" spc="189" dirty="0">
+                <a:solidFill>
+                  <a:srgbClr val="D9A86B"/>
+                </a:solidFill>
+                <a:latin typeface="IBM Plex Mono" pitchFamily="34" charset="0"/>
+                <a:ea typeface="IBM Plex Mono" pitchFamily="34" charset="-122"/>
+                <a:cs typeface="IBM Plex Mono" pitchFamily="34" charset="-120"/>
+              </a:rPr>
+              <a:t>/ TEXT → DATASET</a:t>
+            </a:r>
+            <a:endParaRPr lang="en-US" sz="1350" dirty="0"/>
+          </a:p>
+        </p:txBody>
+      </p:sp>
+      <p:sp>
+        <p:nvSpPr>
+          <p:cNvPr id="5" name="Shape 3"/>
+          <p:cNvSpPr/>
+          <p:nvPr/>
+        </p:nvSpPr>
+        <p:spPr>
+          <a:xfrm>
+            <a:off x="838200" y="1734369"/>
+            <a:ext cx="457200" cy="28575"/>
+          </a:xfrm>
+          <a:prstGeom prst="roundRect">
+            <a:avLst>
+              <a:gd name="adj" fmla="val 50000"/>
+            </a:avLst>
+          </a:prstGeom>
+          <a:solidFill>
+            <a:srgbClr val="EAAA00"/>
+          </a:solidFill>
+          <a:ln/>
+        </p:spPr>
+        <p:txBody>
+          <a:bodyPr/>
+          <a:lstStyle/>
+          <a:p>
+            <a:endParaRPr lang="en-US"/>
+          </a:p>
+        </p:txBody>
+      </p:sp>
+      <p:sp>
+        <p:nvSpPr>
+          <p:cNvPr id="6" name="Text 4"/>
+          <p:cNvSpPr/>
+          <p:nvPr/>
+        </p:nvSpPr>
+        <p:spPr>
+          <a:xfrm>
+            <a:off x="838200" y="1972494"/>
+            <a:ext cx="6863923" cy="1560463"/>
+          </a:xfrm>
+          <a:prstGeom prst="rect">
+            <a:avLst/>
+          </a:prstGeom>
+          <a:noFill/>
+          <a:ln/>
+        </p:spPr>
+        <p:txBody>
+          <a:bodyPr wrap="square" lIns="25400" tIns="25400" rIns="25400" bIns="25400" rtlCol="0" anchor="t">
+            <a:normAutofit fontScale="92500" lnSpcReduction="20000"/>
+          </a:bodyPr>
+          <a:lstStyle/>
+          <a:p>
+            <a:pPr marL="0" indent="0" algn="l">
+              <a:lnSpc>
+                <a:spcPct val="108000"/>
+              </a:lnSpc>
+              <a:buNone/>
+            </a:pPr>
+            <a:r>
+              <a:rPr lang="en-US" sz="5550" b="1" kern="0" spc="-111" dirty="0">
+                <a:solidFill>
+                  <a:srgbClr val="FFFFFF"/>
+                </a:solidFill>
+                <a:latin typeface="Arial" pitchFamily="34" charset="0"/>
+                <a:ea typeface="Arial" pitchFamily="34" charset="-122"/>
+                <a:cs typeface="Arial" pitchFamily="34" charset="-120"/>
+              </a:rPr>
+              <a:t>From papers to a </a:t>
+            </a:r>
+            <a:r>
+              <a:rPr lang="en-US" sz="5550" i="1" kern="0" spc="-111" dirty="0">
+                <a:solidFill>
+                  <a:srgbClr val="EAAA00"/>
+                </a:solidFill>
+                <a:latin typeface="Arial" pitchFamily="34" charset="0"/>
+                <a:ea typeface="Arial" pitchFamily="34" charset="-122"/>
+                <a:cs typeface="Arial" pitchFamily="34" charset="-120"/>
+              </a:rPr>
+              <a:t>clean dataset</a:t>
+            </a:r>
+            <a:endParaRPr lang="en-US" sz="5550" dirty="0"/>
+          </a:p>
+        </p:txBody>
+      </p:sp>
+      <p:sp>
+        <p:nvSpPr>
+          <p:cNvPr id="7" name="Text 5"/>
+          <p:cNvSpPr/>
+          <p:nvPr/>
+        </p:nvSpPr>
+        <p:spPr>
+          <a:xfrm>
+            <a:off x="838200" y="3761556"/>
+            <a:ext cx="7093096" cy="1109663"/>
+          </a:xfrm>
+          <a:prstGeom prst="rect">
+            <a:avLst/>
+          </a:prstGeom>
+          <a:noFill/>
+          <a:ln/>
+        </p:spPr>
+        <p:txBody>
+          <a:bodyPr wrap="square" lIns="25400" tIns="25400" rIns="25400" bIns="25400" rtlCol="0" anchor="t">
+            <a:normAutofit/>
+          </a:bodyPr>
+          <a:lstStyle/>
+          <a:p>
+            <a:pPr marL="0" indent="0" algn="l">
+              <a:lnSpc>
+                <a:spcPct val="150000"/>
+              </a:lnSpc>
+              <a:buNone/>
+            </a:pPr>
+            <a:r>
+              <a:rPr lang="en-US" sz="1875" dirty="0">
+                <a:solidFill>
+                  <a:srgbClr val="E7C9C5"/>
+                </a:solidFill>
+                <a:latin typeface="Arial" pitchFamily="34" charset="0"/>
+                <a:ea typeface="Arial" pitchFamily="34" charset="-122"/>
+                <a:cs typeface="Arial" pitchFamily="34" charset="-120"/>
+              </a:rPr>
+              <a:t>Turn a corpus of papers into a validated table with an LLM.</a:t>
+            </a:r>
+          </a:p>
+          <a:p>
+            <a:pPr marL="0" indent="0" algn="l">
+              <a:lnSpc>
+                <a:spcPct val="150000"/>
+              </a:lnSpc>
+              <a:buNone/>
+            </a:pPr>
+            <a:r>
+              <a:rPr lang="en-US" sz="1875" dirty="0">
+                <a:solidFill>
+                  <a:srgbClr val="E7C9C5"/>
+                </a:solidFill>
+                <a:latin typeface="Arial" pitchFamily="34" charset="0"/>
+                <a:ea typeface="Arial" pitchFamily="34" charset="-122"/>
+                <a:cs typeface="Arial" pitchFamily="34" charset="-120"/>
+              </a:rPr>
+              <a:t>With auto prompt optimization applied. </a:t>
+            </a:r>
+            <a:endParaRPr lang="en-US" sz="1875" dirty="0"/>
+          </a:p>
+        </p:txBody>
+      </p:sp>
+      <p:sp>
+        <p:nvSpPr>
+          <p:cNvPr id="8" name="Shape 6"/>
+          <p:cNvSpPr/>
+          <p:nvPr/>
+        </p:nvSpPr>
+        <p:spPr>
+          <a:xfrm>
+            <a:off x="838200" y="5214119"/>
+            <a:ext cx="2753171" cy="376238"/>
+          </a:xfrm>
+          <a:prstGeom prst="roundRect">
+            <a:avLst>
+              <a:gd name="adj" fmla="val 50000"/>
+            </a:avLst>
+          </a:prstGeom>
+          <a:solidFill>
+            <a:srgbClr val="EAAA00">
+              <a:alpha val="16000"/>
+            </a:srgbClr>
+          </a:solidFill>
+          <a:ln/>
+        </p:spPr>
+        <p:txBody>
+          <a:bodyPr/>
+          <a:lstStyle/>
+          <a:p>
+            <a:endParaRPr lang="en-US"/>
+          </a:p>
+        </p:txBody>
+      </p:sp>
+      <p:sp>
+        <p:nvSpPr>
+          <p:cNvPr id="9" name="Text 7"/>
+          <p:cNvSpPr/>
+          <p:nvPr/>
+        </p:nvSpPr>
+        <p:spPr>
+          <a:xfrm>
+            <a:off x="990600" y="5280794"/>
+            <a:ext cx="2530967" cy="280988"/>
+          </a:xfrm>
+          <a:prstGeom prst="rect">
+            <a:avLst/>
+          </a:prstGeom>
+          <a:noFill/>
+          <a:ln/>
+        </p:spPr>
+        <p:txBody>
+          <a:bodyPr wrap="square" lIns="25400" tIns="25400" rIns="25400" bIns="25400" rtlCol="0" anchor="t">
+            <a:normAutofit fontScale="92500" lnSpcReduction="20000"/>
+          </a:bodyPr>
+          <a:lstStyle/>
+          <a:p>
+            <a:pPr marL="0" indent="0" algn="l">
+              <a:lnSpc>
+                <a:spcPct val="150000"/>
+              </a:lnSpc>
+              <a:buNone/>
+            </a:pPr>
+            <a:r>
+              <a:rPr lang="en-US" sz="1275" kern="0" spc="38" dirty="0">
+                <a:solidFill>
+                  <a:srgbClr val="EAAA00"/>
+                </a:solidFill>
+                <a:latin typeface="IBM Plex Mono" pitchFamily="34" charset="0"/>
+                <a:ea typeface="IBM Plex Mono" pitchFamily="34" charset="-122"/>
+                <a:cs typeface="IBM Plex Mono" pitchFamily="34" charset="-120"/>
+              </a:rPr>
+              <a:t>150 FET-biosensor papers</a:t>
+            </a:r>
+            <a:endParaRPr lang="en-US" sz="1275" dirty="0"/>
+          </a:p>
+        </p:txBody>
+      </p:sp>
+      <p:sp>
+        <p:nvSpPr>
+          <p:cNvPr id="10" name="Shape 8"/>
+          <p:cNvSpPr/>
+          <p:nvPr/>
+        </p:nvSpPr>
+        <p:spPr>
+          <a:xfrm>
+            <a:off x="3686621" y="5214119"/>
+            <a:ext cx="1120973" cy="376238"/>
+          </a:xfrm>
+          <a:prstGeom prst="roundRect">
+            <a:avLst>
+              <a:gd name="adj" fmla="val 50000"/>
+            </a:avLst>
+          </a:prstGeom>
+          <a:solidFill>
+            <a:srgbClr val="EAAA00">
+              <a:alpha val="16000"/>
+            </a:srgbClr>
+          </a:solidFill>
+          <a:ln/>
+        </p:spPr>
+        <p:txBody>
+          <a:bodyPr/>
+          <a:lstStyle/>
+          <a:p>
+            <a:endParaRPr lang="en-US"/>
+          </a:p>
+        </p:txBody>
+      </p:sp>
+      <p:sp>
+        <p:nvSpPr>
+          <p:cNvPr id="11" name="Text 9"/>
+          <p:cNvSpPr/>
+          <p:nvPr/>
+        </p:nvSpPr>
+        <p:spPr>
+          <a:xfrm>
+            <a:off x="3839021" y="5280794"/>
+            <a:ext cx="892373" cy="280988"/>
+          </a:xfrm>
+          <a:prstGeom prst="rect">
+            <a:avLst/>
+          </a:prstGeom>
+          <a:noFill/>
+          <a:ln/>
+        </p:spPr>
+        <p:txBody>
+          <a:bodyPr wrap="square" lIns="25400" tIns="25400" rIns="25400" bIns="25400" rtlCol="0" anchor="t">
+            <a:normAutofit fontScale="92500" lnSpcReduction="20000"/>
+          </a:bodyPr>
+          <a:lstStyle/>
+          <a:p>
+            <a:pPr marL="0" indent="0" algn="l">
+              <a:lnSpc>
+                <a:spcPct val="150000"/>
+              </a:lnSpc>
+              <a:buNone/>
+            </a:pPr>
+            <a:r>
+              <a:rPr lang="en-US" sz="1275" kern="0" spc="38" dirty="0">
+                <a:solidFill>
+                  <a:srgbClr val="EAAA00"/>
+                </a:solidFill>
+                <a:latin typeface="IBM Plex Mono" pitchFamily="34" charset="0"/>
+                <a:ea typeface="IBM Plex Mono" pitchFamily="34" charset="-122"/>
+                <a:cs typeface="IBM Plex Mono" pitchFamily="34" charset="-120"/>
+              </a:rPr>
+              <a:t>8 fields</a:t>
+            </a:r>
+            <a:endParaRPr lang="en-US" sz="1275" dirty="0"/>
+          </a:p>
+        </p:txBody>
+      </p:sp>
+      <p:sp>
+        <p:nvSpPr>
+          <p:cNvPr id="14" name="Shape 12"/>
+          <p:cNvSpPr/>
+          <p:nvPr/>
+        </p:nvSpPr>
+        <p:spPr>
+          <a:xfrm>
+            <a:off x="762000" y="6176963"/>
+            <a:ext cx="10668000" cy="9525"/>
+          </a:xfrm>
+          <a:prstGeom prst="rect">
+            <a:avLst/>
+          </a:prstGeom>
+          <a:solidFill>
+            <a:srgbClr val="FFFFFF">
+              <a:alpha val="12000"/>
+            </a:srgbClr>
+          </a:solidFill>
+          <a:ln/>
+        </p:spPr>
+        <p:txBody>
+          <a:bodyPr/>
+          <a:lstStyle/>
+          <a:p>
+            <a:endParaRPr lang="en-US"/>
+          </a:p>
+        </p:txBody>
+      </p:sp>
+      <p:sp>
+        <p:nvSpPr>
+          <p:cNvPr id="15" name="Text 13"/>
+          <p:cNvSpPr/>
+          <p:nvPr/>
+        </p:nvSpPr>
+        <p:spPr>
+          <a:xfrm>
+            <a:off x="762000" y="6319838"/>
+            <a:ext cx="2527995" cy="252413"/>
+          </a:xfrm>
+          <a:prstGeom prst="rect">
+            <a:avLst/>
+          </a:prstGeom>
+          <a:noFill/>
+          <a:ln/>
+        </p:spPr>
+        <p:txBody>
+          <a:bodyPr wrap="square" lIns="25400" tIns="25400" rIns="25400" bIns="25400" rtlCol="0" anchor="t">
+            <a:normAutofit fontScale="92500" lnSpcReduction="10000"/>
+          </a:bodyPr>
+          <a:lstStyle/>
+          <a:p>
+            <a:pPr marL="0" indent="0" algn="l">
+              <a:lnSpc>
+                <a:spcPct val="150000"/>
+              </a:lnSpc>
+              <a:buNone/>
+            </a:pPr>
+            <a:r>
+              <a:rPr lang="en-US" sz="1125" kern="0" spc="68" dirty="0">
+                <a:solidFill>
+                  <a:srgbClr val="EAAA00"/>
+                </a:solidFill>
+                <a:latin typeface="IBM Plex Mono" pitchFamily="34" charset="0"/>
+                <a:ea typeface="IBM Plex Mono" pitchFamily="34" charset="-122"/>
+                <a:cs typeface="IBM Plex Mono" pitchFamily="34" charset="-120"/>
+              </a:rPr>
+              <a:t>UChicago PME · AI Training</a:t>
+            </a:r>
+            <a:endParaRPr lang="en-US" sz="1125" dirty="0"/>
+          </a:p>
+        </p:txBody>
+      </p:sp>
+      <p:sp>
+        <p:nvSpPr>
+          <p:cNvPr id="16" name="Text 14"/>
+          <p:cNvSpPr/>
+          <p:nvPr/>
+        </p:nvSpPr>
+        <p:spPr>
+          <a:xfrm>
+            <a:off x="9166845" y="6319838"/>
+            <a:ext cx="2339355" cy="252413"/>
+          </a:xfrm>
+          <a:prstGeom prst="rect">
+            <a:avLst/>
+          </a:prstGeom>
+          <a:noFill/>
+          <a:ln/>
+        </p:spPr>
+        <p:txBody>
+          <a:bodyPr wrap="square" lIns="25400" tIns="25400" rIns="25400" bIns="25400" rtlCol="0" anchor="t">
+            <a:normAutofit fontScale="92500" lnSpcReduction="10000"/>
+          </a:bodyPr>
+          <a:lstStyle/>
+          <a:p>
+            <a:pPr marL="0" indent="0" algn="l">
+              <a:lnSpc>
+                <a:spcPct val="150000"/>
+              </a:lnSpc>
+              <a:buNone/>
+            </a:pPr>
+            <a:r>
+              <a:rPr lang="en-US" sz="1125" kern="0" spc="68" dirty="0">
+                <a:solidFill>
+                  <a:srgbClr val="B3756F"/>
+                </a:solidFill>
+                <a:latin typeface="IBM Plex Mono" pitchFamily="34" charset="0"/>
+                <a:ea typeface="IBM Plex Mono" pitchFamily="34" charset="-122"/>
+                <a:cs typeface="IBM Plex Mono" pitchFamily="34" charset="-120"/>
+              </a:rPr>
+              <a:t>Module 2a — Text to data</a:t>
+            </a:r>
+            <a:endParaRPr lang="en-US" sz="1125" dirty="0"/>
+          </a:p>
+        </p:txBody>
+      </p:sp>
+    </p:spTree>
+  </p:cSld>
+  <p:clrMapOvr>
+    <a:masterClrMapping/>
+  </p:clrMapOvr>
+</p:sld>
+</file>
+
+<file path=ppt/slides/slide12.xml><?xml version="1.0" encoding="utf-8"?>
+<p:sld xmlns:a="http://schemas.openxmlformats.org/drawingml/2006/main" xmlns:r="http://schemas.openxmlformats.org/officeDocument/2006/relationships" xmlns:p="http://schemas.openxmlformats.org/presentationml/2006/main">
   <p:cSld name="Slide 10">
     <p:bg>
       <p:bgPr>
@@ -3718,7 +5406,7 @@
 </p:sld>
 </file>
 
-<file path=ppt/slides/slide11.xml><?xml version="1.0" encoding="utf-8"?>
+<file path=ppt/slides/slide13.xml><?xml version="1.0" encoding="utf-8"?>
 <p:sld xmlns:a="http://schemas.openxmlformats.org/drawingml/2006/main" xmlns:r="http://schemas.openxmlformats.org/officeDocument/2006/relationships" xmlns:p="http://schemas.openxmlformats.org/presentationml/2006/main">
   <p:cSld>
     <p:spTree>
@@ -4107,10 +5795,10 @@
           <p:nvPr/>
         </p:nvPicPr>
         <p:blipFill>
-          <a:blip r:embed="rId3">
+          <a:blip>
             <a:extLst>
               <a:ext uri="{96DAC541-7B7A-43D3-8B79-37D633B846F1}">
-                <asvg:svgBlip xmlns:asvg="http://schemas.microsoft.com/office/drawing/2016/SVG/main" r:embed="rId4"/>
+                <asvg:svgBlip xmlns:asvg="http://schemas.microsoft.com/office/drawing/2016/SVG/main" r:embed="rId3"/>
               </a:ext>
             </a:extLst>
           </a:blip>
@@ -4143,10 +5831,10 @@
           <p:nvPr/>
         </p:nvPicPr>
         <p:blipFill>
-          <a:blip r:embed="rId5">
+          <a:blip>
             <a:extLst>
               <a:ext uri="{96DAC541-7B7A-43D3-8B79-37D633B846F1}">
-                <asvg:svgBlip xmlns:asvg="http://schemas.microsoft.com/office/drawing/2016/SVG/main" r:embed="rId6"/>
+                <asvg:svgBlip xmlns:asvg="http://schemas.microsoft.com/office/drawing/2016/SVG/main" r:embed="rId4"/>
               </a:ext>
             </a:extLst>
           </a:blip>
@@ -4179,7 +5867,7 @@
           <p:nvPr/>
         </p:nvPicPr>
         <p:blipFill>
-          <a:blip r:embed="rId7">
+          <a:blip r:embed="rId5">
             <a:extLst>
               <a:ext uri="{28A0092B-C50C-407E-A947-70E740481C1C}">
                 <a14:useLocalDpi xmlns:a14="http://schemas.microsoft.com/office/drawing/2010/main" val="0"/>
@@ -4487,7 +6175,7 @@
 </p:sld>
 </file>
 
-<file path=ppt/slides/slide12.xml><?xml version="1.0" encoding="utf-8"?>
+<file path=ppt/slides/slide14.xml><?xml version="1.0" encoding="utf-8"?>
 <p:sld xmlns:a="http://schemas.openxmlformats.org/drawingml/2006/main" xmlns:r="http://schemas.openxmlformats.org/officeDocument/2006/relationships" xmlns:p="http://schemas.openxmlformats.org/presentationml/2006/main">
   <p:cSld name="Slide 11">
     <p:bg>
@@ -5217,7 +6905,7 @@
 </p:sld>
 </file>
 
-<file path=ppt/slides/slide13.xml><?xml version="1.0" encoding="utf-8"?>
+<file path=ppt/slides/slide15.xml><?xml version="1.0" encoding="utf-8"?>
 <p:sld xmlns:a="http://schemas.openxmlformats.org/drawingml/2006/main" xmlns:r="http://schemas.openxmlformats.org/officeDocument/2006/relationships" xmlns:p="http://schemas.openxmlformats.org/presentationml/2006/main">
   <p:cSld name="Slide 12">
     <p:bg>
@@ -5424,7 +7112,29 @@
                 <a:ea typeface="Arial" pitchFamily="34" charset="-122"/>
                 <a:cs typeface="Arial" pitchFamily="34" charset="-120"/>
               </a:rPr>
-              <a:t>Read the page, not just the </a:t>
+              <a:t>Read the page, beyond</a:t>
+            </a:r>
+            <a:r>
+              <a:rPr lang="zh-CN" altLang="en-US" sz="5550" b="1" kern="0" spc="-111" dirty="0">
+                <a:solidFill>
+                  <a:srgbClr val="FFFFFF"/>
+                </a:solidFill>
+                <a:latin typeface="Arial" pitchFamily="34" charset="0"/>
+                <a:ea typeface="Arial" pitchFamily="34" charset="-122"/>
+                <a:cs typeface="Arial" pitchFamily="34" charset="-120"/>
+              </a:rPr>
+              <a:t> </a:t>
+            </a:r>
+            <a:r>
+              <a:rPr lang="en-US" sz="5550" b="1" kern="0" spc="-111" dirty="0">
+                <a:solidFill>
+                  <a:srgbClr val="FFFFFF"/>
+                </a:solidFill>
+                <a:latin typeface="Arial" pitchFamily="34" charset="0"/>
+                <a:ea typeface="Arial" pitchFamily="34" charset="-122"/>
+                <a:cs typeface="Arial" pitchFamily="34" charset="-120"/>
+              </a:rPr>
+              <a:t>just the </a:t>
             </a:r>
             <a:r>
               <a:rPr lang="en-US" sz="5550" i="1" kern="0" spc="-111" dirty="0">
@@ -5610,7 +7320,7 @@
 </p:sld>
 </file>
 
-<file path=ppt/slides/slide14.xml><?xml version="1.0" encoding="utf-8"?>
+<file path=ppt/slides/slide16.xml><?xml version="1.0" encoding="utf-8"?>
 <p:sld xmlns:a="http://schemas.openxmlformats.org/drawingml/2006/main" xmlns:r="http://schemas.openxmlformats.org/officeDocument/2006/relationships" xmlns:p="http://schemas.openxmlformats.org/presentationml/2006/main">
   <p:cSld name="Slide 13">
     <p:bg>
@@ -5831,7 +7541,7 @@
         </p:nvSpPr>
         <p:spPr>
           <a:xfrm>
-            <a:off x="762000" y="3037805"/>
+            <a:off x="762000" y="2860446"/>
             <a:ext cx="1000646" cy="280988"/>
           </a:xfrm>
           <a:prstGeom prst="rect">
@@ -5842,7 +7552,7 @@
         </p:spPr>
         <p:txBody>
           <a:bodyPr wrap="square" lIns="25400" tIns="25400" rIns="25400" bIns="25400" rtlCol="0" anchor="t">
-            <a:normAutofit fontScale="92500" lnSpcReduction="20000"/>
+            <a:noAutofit/>
           </a:bodyPr>
           <a:lstStyle/>
           <a:p>
@@ -5853,7 +7563,7 @@
               <a:buNone/>
             </a:pPr>
             <a:r>
-              <a:rPr lang="en-US" sz="1275" kern="0" spc="127" dirty="0">
+              <a:rPr lang="en-US" sz="800" kern="0" spc="127" dirty="0">
                 <a:solidFill>
                   <a:srgbClr val="6E665E"/>
                 </a:solidFill>
@@ -5861,9 +7571,27 @@
                 <a:ea typeface="IBM Plex Mono" pitchFamily="34" charset="-122"/>
                 <a:cs typeface="IBM Plex Mono" pitchFamily="34" charset="-120"/>
               </a:rPr>
-              <a:t>TEXT F1</a:t>
-            </a:r>
-            <a:endParaRPr lang="en-US" sz="1275" dirty="0"/>
+              <a:t>TEXT</a:t>
+            </a:r>
+          </a:p>
+          <a:p>
+            <a:pPr marL="0" indent="0" algn="l">
+              <a:lnSpc>
+                <a:spcPct val="150000"/>
+              </a:lnSpc>
+              <a:buNone/>
+            </a:pPr>
+            <a:r>
+              <a:rPr lang="en-US" sz="800" kern="0" spc="127" dirty="0">
+                <a:solidFill>
+                  <a:srgbClr val="6E665E"/>
+                </a:solidFill>
+                <a:latin typeface="IBM Plex Mono" pitchFamily="34" charset="0"/>
+                <a:ea typeface="IBM Plex Mono" pitchFamily="34" charset="-122"/>
+                <a:cs typeface="IBM Plex Mono" pitchFamily="34" charset="-120"/>
+              </a:rPr>
+              <a:t>PRECISION</a:t>
+            </a:r>
           </a:p>
         </p:txBody>
       </p:sp>
@@ -5946,7 +7674,7 @@
         </p:nvSpPr>
         <p:spPr>
           <a:xfrm>
-            <a:off x="2381771" y="3037805"/>
+            <a:off x="2381771" y="2860446"/>
             <a:ext cx="2030090" cy="280988"/>
           </a:xfrm>
           <a:prstGeom prst="rect">
@@ -5957,7 +7685,7 @@
         </p:spPr>
         <p:txBody>
           <a:bodyPr wrap="square" lIns="25400" tIns="25400" rIns="25400" bIns="25400" rtlCol="0" anchor="t">
-            <a:normAutofit fontScale="92500" lnSpcReduction="20000"/>
+            <a:noAutofit/>
           </a:bodyPr>
           <a:lstStyle/>
           <a:p>
@@ -5968,7 +7696,7 @@
               <a:buNone/>
             </a:pPr>
             <a:r>
-              <a:rPr lang="en-US" sz="1275" kern="0" spc="127" dirty="0">
+              <a:rPr lang="en-US" sz="800" kern="0" spc="127" dirty="0">
                 <a:solidFill>
                   <a:srgbClr val="6E665E"/>
                 </a:solidFill>
@@ -5976,9 +7704,28 @@
                 <a:ea typeface="IBM Plex Mono" pitchFamily="34" charset="-122"/>
                 <a:cs typeface="IBM Plex Mono" pitchFamily="34" charset="-120"/>
               </a:rPr>
-              <a:t>IMAGE F1</a:t>
-            </a:r>
-            <a:endParaRPr lang="en-US" sz="1275" dirty="0"/>
+              <a:t>IMAGE </a:t>
+            </a:r>
+          </a:p>
+          <a:p>
+            <a:pPr marL="0" indent="0" algn="l">
+              <a:lnSpc>
+                <a:spcPct val="150000"/>
+              </a:lnSpc>
+              <a:buNone/>
+            </a:pPr>
+            <a:r>
+              <a:rPr lang="en-US" sz="800" kern="0" spc="127" dirty="0">
+                <a:solidFill>
+                  <a:srgbClr val="6E665E"/>
+                </a:solidFill>
+                <a:latin typeface="IBM Plex Mono" pitchFamily="34" charset="0"/>
+                <a:ea typeface="IBM Plex Mono" pitchFamily="34" charset="-122"/>
+                <a:cs typeface="IBM Plex Mono" pitchFamily="34" charset="-120"/>
+              </a:rPr>
+              <a:t>PRECISION</a:t>
+            </a:r>
+            <a:endParaRPr lang="en-US" sz="800" dirty="0"/>
           </a:p>
         </p:txBody>
       </p:sp>
@@ -6014,57 +7761,138 @@
             <a:r>
               <a:rPr lang="en-US" sz="3900" b="1" kern="0" spc="-78" dirty="0">
                 <a:solidFill>
-                  <a:srgbClr val="1A1714"/>
+                  <a:srgbClr val="FF0000"/>
                 </a:solidFill>
                 <a:latin typeface="Arial" pitchFamily="34" charset="0"/>
                 <a:ea typeface="Arial" pitchFamily="34" charset="-122"/>
                 <a:cs typeface="Arial" pitchFamily="34" charset="-120"/>
               </a:rPr>
-              <a:t>0.69</a:t>
-            </a:r>
-            <a:endParaRPr lang="en-US" sz="3900" dirty="0"/>
-          </a:p>
-        </p:txBody>
-      </p:sp>
-      <p:sp>
-        <p:nvSpPr>
-          <p:cNvPr id="12" name="Text 10"/>
-          <p:cNvSpPr/>
-          <p:nvPr/>
-        </p:nvSpPr>
-        <p:spPr>
-          <a:xfrm>
-            <a:off x="2381771" y="3966493"/>
-            <a:ext cx="2030090" cy="295275"/>
-          </a:xfrm>
-          <a:prstGeom prst="rect">
-            <a:avLst/>
-          </a:prstGeom>
-          <a:noFill/>
-          <a:ln/>
-        </p:spPr>
-        <p:txBody>
-          <a:bodyPr wrap="square" lIns="25400" tIns="25400" rIns="25400" bIns="25400" rtlCol="0" anchor="t">
-            <a:normAutofit fontScale="92500" lnSpcReduction="10000"/>
-          </a:bodyPr>
-          <a:lstStyle/>
-          <a:p>
-            <a:pPr marL="0" indent="0" algn="l">
-              <a:lnSpc>
-                <a:spcPct val="150000"/>
-              </a:lnSpc>
-              <a:buNone/>
-            </a:pPr>
-            <a:r>
-              <a:rPr lang="en-US" sz="1350" dirty="0">
-                <a:solidFill>
-                  <a:srgbClr val="6E665E"/>
+              <a:t>0.</a:t>
+            </a:r>
+            <a:r>
+              <a:rPr lang="en-US" altLang="zh-CN" sz="3900" b="1" kern="0" spc="-78" dirty="0">
+                <a:solidFill>
+                  <a:srgbClr val="FF0000"/>
                 </a:solidFill>
                 <a:latin typeface="Arial" pitchFamily="34" charset="0"/>
                 <a:ea typeface="Arial" pitchFamily="34" charset="-122"/>
                 <a:cs typeface="Arial" pitchFamily="34" charset="-120"/>
               </a:rPr>
-              <a:t>but precision 0.81 vs 0.68</a:t>
+              <a:t>81</a:t>
+            </a:r>
+            <a:endParaRPr lang="en-US" sz="3900" dirty="0">
+              <a:solidFill>
+                <a:srgbClr val="FF0000"/>
+              </a:solidFill>
+            </a:endParaRPr>
+          </a:p>
+        </p:txBody>
+      </p:sp>
+      <p:sp>
+        <p:nvSpPr>
+          <p:cNvPr id="12" name="Text 10"/>
+          <p:cNvSpPr/>
+          <p:nvPr/>
+        </p:nvSpPr>
+        <p:spPr>
+          <a:xfrm>
+            <a:off x="2381771" y="3966493"/>
+            <a:ext cx="2030090" cy="295275"/>
+          </a:xfrm>
+          <a:prstGeom prst="rect">
+            <a:avLst/>
+          </a:prstGeom>
+          <a:noFill/>
+          <a:ln/>
+        </p:spPr>
+        <p:txBody>
+          <a:bodyPr wrap="square" lIns="25400" tIns="25400" rIns="25400" bIns="25400" rtlCol="0" anchor="t">
+            <a:normAutofit fontScale="92500" lnSpcReduction="10000"/>
+          </a:bodyPr>
+          <a:lstStyle/>
+          <a:p>
+            <a:pPr marL="0" indent="0" algn="l">
+              <a:lnSpc>
+                <a:spcPct val="150000"/>
+              </a:lnSpc>
+              <a:buNone/>
+            </a:pPr>
+            <a:r>
+              <a:rPr lang="en-US" sz="1350" dirty="0">
+                <a:solidFill>
+                  <a:srgbClr val="6E665E"/>
+                </a:solidFill>
+                <a:latin typeface="Arial" pitchFamily="34" charset="0"/>
+                <a:ea typeface="Arial" pitchFamily="34" charset="-122"/>
+                <a:cs typeface="Arial" pitchFamily="34" charset="-120"/>
+              </a:rPr>
+              <a:t>F</a:t>
+            </a:r>
+            <a:r>
+              <a:rPr lang="en-US" altLang="zh-CN" sz="1350" dirty="0">
+                <a:solidFill>
+                  <a:srgbClr val="6E665E"/>
+                </a:solidFill>
+                <a:latin typeface="Arial" pitchFamily="34" charset="0"/>
+                <a:ea typeface="Arial" pitchFamily="34" charset="-122"/>
+                <a:cs typeface="Arial" pitchFamily="34" charset="-120"/>
+              </a:rPr>
+              <a:t>1</a:t>
+            </a:r>
+            <a:r>
+              <a:rPr lang="zh-CN" altLang="en-US" sz="1350" dirty="0">
+                <a:solidFill>
+                  <a:srgbClr val="6E665E"/>
+                </a:solidFill>
+                <a:latin typeface="Arial" pitchFamily="34" charset="0"/>
+                <a:ea typeface="Arial" pitchFamily="34" charset="-122"/>
+                <a:cs typeface="Arial" pitchFamily="34" charset="-120"/>
+              </a:rPr>
+              <a:t> </a:t>
+            </a:r>
+            <a:r>
+              <a:rPr lang="en-US" sz="1350" dirty="0">
+                <a:solidFill>
+                  <a:srgbClr val="6E665E"/>
+                </a:solidFill>
+                <a:latin typeface="Arial" pitchFamily="34" charset="0"/>
+                <a:ea typeface="Arial" pitchFamily="34" charset="-122"/>
+                <a:cs typeface="Arial" pitchFamily="34" charset="-120"/>
+              </a:rPr>
+              <a:t>0.</a:t>
+            </a:r>
+            <a:r>
+              <a:rPr lang="en-US" altLang="zh-CN" sz="1350" dirty="0">
+                <a:solidFill>
+                  <a:srgbClr val="6E665E"/>
+                </a:solidFill>
+                <a:latin typeface="Arial" pitchFamily="34" charset="0"/>
+                <a:ea typeface="Arial" pitchFamily="34" charset="-122"/>
+                <a:cs typeface="Arial" pitchFamily="34" charset="-120"/>
+              </a:rPr>
+              <a:t>68</a:t>
+            </a:r>
+            <a:r>
+              <a:rPr lang="en-US" sz="1350" dirty="0">
+                <a:solidFill>
+                  <a:srgbClr val="6E665E"/>
+                </a:solidFill>
+                <a:latin typeface="Arial" pitchFamily="34" charset="0"/>
+                <a:ea typeface="Arial" pitchFamily="34" charset="-122"/>
+                <a:cs typeface="Arial" pitchFamily="34" charset="-120"/>
+              </a:rPr>
+              <a:t> vs 0.6</a:t>
+            </a:r>
+            <a:r>
+              <a:rPr lang="en-US" altLang="zh-CN" sz="1350" dirty="0">
+                <a:solidFill>
+                  <a:srgbClr val="6E665E"/>
+                </a:solidFill>
+                <a:latin typeface="Arial" pitchFamily="34" charset="0"/>
+                <a:ea typeface="Arial" pitchFamily="34" charset="-122"/>
+                <a:cs typeface="Arial" pitchFamily="34" charset="-120"/>
+              </a:rPr>
+              <a:t>9</a:t>
             </a:r>
             <a:endParaRPr lang="en-US" sz="1350" dirty="0"/>
           </a:p>
@@ -6445,7 +8273,7 @@
 </p:sld>
 </file>
 
-<file path=ppt/slides/slide15.xml><?xml version="1.0" encoding="utf-8"?>
+<file path=ppt/slides/slide17.xml><?xml version="1.0" encoding="utf-8"?>
 <p:sld xmlns:a="http://schemas.openxmlformats.org/drawingml/2006/main" xmlns:r="http://schemas.openxmlformats.org/officeDocument/2006/relationships" xmlns:p="http://schemas.openxmlformats.org/presentationml/2006/main">
   <p:cSld name="Slide 14">
     <p:bg>
@@ -6936,6 +8764,28 @@
               </a:rPr>
               <a:t>with an exhaustive prompt</a:t>
             </a:r>
+            <a:r>
+              <a:rPr lang="zh-CN" altLang="en-US" sz="1725" dirty="0">
+                <a:solidFill>
+                  <a:srgbClr val="403B36"/>
+                </a:solidFill>
+                <a:latin typeface="Arial" pitchFamily="34" charset="0"/>
+                <a:ea typeface="Arial" pitchFamily="34" charset="-122"/>
+                <a:cs typeface="Arial" pitchFamily="34" charset="-120"/>
+              </a:rPr>
+              <a:t> </a:t>
+            </a:r>
+            <a:r>
+              <a:rPr lang="en-US" altLang="zh-CN" sz="1725" dirty="0">
+                <a:solidFill>
+                  <a:srgbClr val="403B36"/>
+                </a:solidFill>
+                <a:latin typeface="Arial" pitchFamily="34" charset="0"/>
+                <a:ea typeface="Arial" pitchFamily="34" charset="-122"/>
+                <a:cs typeface="Arial" pitchFamily="34" charset="-120"/>
+              </a:rPr>
+              <a:t>(basic multi-agent)</a:t>
+            </a:r>
             <a:endParaRPr lang="en-US" sz="1725" dirty="0"/>
           </a:p>
         </p:txBody>
@@ -7210,6 +9060,1138 @@
         </p:spPr>
       </p:pic>
     </p:spTree>
+  </p:cSld>
+  <p:clrMapOvr>
+    <a:masterClrMapping/>
+  </p:clrMapOvr>
+</p:sld>
+</file>
+
+<file path=ppt/slides/slide18.xml><?xml version="1.0" encoding="utf-8"?>
+<p:sld xmlns:a="http://schemas.openxmlformats.org/drawingml/2006/main" xmlns:r="http://schemas.openxmlformats.org/officeDocument/2006/relationships" xmlns:p="http://schemas.openxmlformats.org/presentationml/2006/main">
+  <p:cSld>
+    <p:spTree>
+      <p:nvGrpSpPr>
+        <p:cNvPr id="1" name="">
+          <a:extLst>
+            <a:ext uri="{FF2B5EF4-FFF2-40B4-BE49-F238E27FC236}">
+              <a16:creationId xmlns:a16="http://schemas.microsoft.com/office/drawing/2014/main" id="{B99AB28F-3195-2E45-8228-8DAC638DBFFD}"/>
+            </a:ext>
+          </a:extLst>
+        </p:cNvPr>
+        <p:cNvGrpSpPr/>
+        <p:nvPr/>
+      </p:nvGrpSpPr>
+      <p:grpSpPr>
+        <a:xfrm>
+          <a:off x="0" y="0"/>
+          <a:ext cx="0" cy="0"/>
+          <a:chOff x="0" y="0"/>
+          <a:chExt cx="0" cy="0"/>
+        </a:xfrm>
+      </p:grpSpPr>
+      <p:sp>
+        <p:nvSpPr>
+          <p:cNvPr id="2" name="Shape 0">
+            <a:extLst>
+              <a:ext uri="{FF2B5EF4-FFF2-40B4-BE49-F238E27FC236}">
+                <a16:creationId xmlns:a16="http://schemas.microsoft.com/office/drawing/2014/main" id="{B5026C2A-FD5C-829C-BC5A-CC047DCCFC12}"/>
+              </a:ext>
+            </a:extLst>
+          </p:cNvPr>
+          <p:cNvSpPr/>
+          <p:nvPr/>
+        </p:nvSpPr>
+        <p:spPr>
+          <a:xfrm>
+            <a:off x="0" y="0"/>
+            <a:ext cx="12192000" cy="6858000"/>
+          </a:xfrm>
+          <a:prstGeom prst="rect">
+            <a:avLst/>
+          </a:prstGeom>
+          <a:solidFill>
+            <a:srgbClr val="3D0000"/>
+          </a:solidFill>
+          <a:ln/>
+        </p:spPr>
+        <p:txBody>
+          <a:bodyPr/>
+          <a:lstStyle/>
+          <a:p>
+            <a:endParaRPr lang="en-US"/>
+          </a:p>
+        </p:txBody>
+      </p:sp>
+      <p:sp>
+        <p:nvSpPr>
+          <p:cNvPr id="3" name="Text 1">
+            <a:extLst>
+              <a:ext uri="{FF2B5EF4-FFF2-40B4-BE49-F238E27FC236}">
+                <a16:creationId xmlns:a16="http://schemas.microsoft.com/office/drawing/2014/main" id="{A7CB391C-C113-6334-36D7-E4A81A2C4ABB}"/>
+              </a:ext>
+            </a:extLst>
+          </p:cNvPr>
+          <p:cNvSpPr/>
+          <p:nvPr/>
+        </p:nvSpPr>
+        <p:spPr>
+          <a:xfrm>
+            <a:off x="838200" y="1281931"/>
+            <a:ext cx="1218084" cy="261937"/>
+          </a:xfrm>
+          <a:prstGeom prst="rect">
+            <a:avLst/>
+          </a:prstGeom>
+          <a:noFill/>
+          <a:ln/>
+        </p:spPr>
+        <p:txBody>
+          <a:bodyPr wrap="square" lIns="0" tIns="0" rIns="0" bIns="0" rtlCol="0" anchor="t">
+            <a:normAutofit lnSpcReduction="10000"/>
+          </a:bodyPr>
+          <a:lstStyle/>
+          <a:p>
+            <a:pPr marL="0" indent="0" algn="l">
+              <a:lnSpc>
+                <a:spcPct val="150000"/>
+              </a:lnSpc>
+              <a:buNone/>
+            </a:pPr>
+            <a:r>
+              <a:rPr lang="en-US" sz="1350" kern="0" spc="189" dirty="0">
+                <a:solidFill>
+                  <a:srgbClr val="EAAA00"/>
+                </a:solidFill>
+                <a:latin typeface="IBM Plex Mono" pitchFamily="34" charset="0"/>
+                <a:ea typeface="IBM Plex Mono" pitchFamily="34" charset="-122"/>
+                <a:cs typeface="IBM Plex Mono" pitchFamily="34" charset="-120"/>
+              </a:rPr>
+              <a:t>MODULE 3</a:t>
+            </a:r>
+            <a:endParaRPr lang="en-US" sz="1350" dirty="0"/>
+          </a:p>
+        </p:txBody>
+      </p:sp>
+      <p:sp>
+        <p:nvSpPr>
+          <p:cNvPr id="4" name="Text 2">
+            <a:extLst>
+              <a:ext uri="{FF2B5EF4-FFF2-40B4-BE49-F238E27FC236}">
+                <a16:creationId xmlns:a16="http://schemas.microsoft.com/office/drawing/2014/main" id="{EFDCCB2F-AC31-F900-FB59-1477FD8E4322}"/>
+              </a:ext>
+            </a:extLst>
+          </p:cNvPr>
+          <p:cNvSpPr/>
+          <p:nvPr/>
+        </p:nvSpPr>
+        <p:spPr>
+          <a:xfrm>
+            <a:off x="2094383" y="1267645"/>
+            <a:ext cx="3413037" cy="276224"/>
+          </a:xfrm>
+          <a:prstGeom prst="rect">
+            <a:avLst/>
+          </a:prstGeom>
+          <a:noFill/>
+          <a:ln/>
+        </p:spPr>
+        <p:txBody>
+          <a:bodyPr wrap="square" lIns="25400" tIns="25400" rIns="25400" bIns="25400" rtlCol="0" anchor="t">
+            <a:normAutofit fontScale="92500" lnSpcReduction="20000"/>
+          </a:bodyPr>
+          <a:lstStyle/>
+          <a:p>
+            <a:pPr marL="0" indent="0" algn="l">
+              <a:lnSpc>
+                <a:spcPct val="150000"/>
+              </a:lnSpc>
+              <a:buNone/>
+            </a:pPr>
+            <a:r>
+              <a:rPr lang="en-US" sz="1350" kern="0" spc="189" dirty="0">
+                <a:solidFill>
+                  <a:srgbClr val="D9A86B"/>
+                </a:solidFill>
+                <a:latin typeface="IBM Plex Mono" pitchFamily="34" charset="0"/>
+                <a:ea typeface="IBM Plex Mono" pitchFamily="34" charset="-122"/>
+                <a:cs typeface="IBM Plex Mono" pitchFamily="34" charset="-120"/>
+              </a:rPr>
+              <a:t>/ DISTILATION &amp; FINE TUNING</a:t>
+            </a:r>
+            <a:endParaRPr lang="en-US" sz="1350" dirty="0"/>
+          </a:p>
+        </p:txBody>
+      </p:sp>
+      <p:sp>
+        <p:nvSpPr>
+          <p:cNvPr id="5" name="Shape 3">
+            <a:extLst>
+              <a:ext uri="{FF2B5EF4-FFF2-40B4-BE49-F238E27FC236}">
+                <a16:creationId xmlns:a16="http://schemas.microsoft.com/office/drawing/2014/main" id="{8B1A113A-C50E-121A-C439-BF8000893F48}"/>
+              </a:ext>
+            </a:extLst>
+          </p:cNvPr>
+          <p:cNvSpPr/>
+          <p:nvPr/>
+        </p:nvSpPr>
+        <p:spPr>
+          <a:xfrm>
+            <a:off x="838200" y="1734369"/>
+            <a:ext cx="457200" cy="28575"/>
+          </a:xfrm>
+          <a:prstGeom prst="roundRect">
+            <a:avLst>
+              <a:gd name="adj" fmla="val 50000"/>
+            </a:avLst>
+          </a:prstGeom>
+          <a:solidFill>
+            <a:srgbClr val="EAAA00"/>
+          </a:solidFill>
+          <a:ln/>
+        </p:spPr>
+        <p:txBody>
+          <a:bodyPr/>
+          <a:lstStyle/>
+          <a:p>
+            <a:endParaRPr lang="en-US"/>
+          </a:p>
+        </p:txBody>
+      </p:sp>
+      <p:sp>
+        <p:nvSpPr>
+          <p:cNvPr id="6" name="Text 4">
+            <a:extLst>
+              <a:ext uri="{FF2B5EF4-FFF2-40B4-BE49-F238E27FC236}">
+                <a16:creationId xmlns:a16="http://schemas.microsoft.com/office/drawing/2014/main" id="{2D898F96-950C-8E90-E626-0BACE585238D}"/>
+              </a:ext>
+            </a:extLst>
+          </p:cNvPr>
+          <p:cNvSpPr/>
+          <p:nvPr/>
+        </p:nvSpPr>
+        <p:spPr>
+          <a:xfrm>
+            <a:off x="838199" y="1972494"/>
+            <a:ext cx="8140005" cy="1560463"/>
+          </a:xfrm>
+          <a:prstGeom prst="rect">
+            <a:avLst/>
+          </a:prstGeom>
+          <a:noFill/>
+          <a:ln/>
+        </p:spPr>
+        <p:txBody>
+          <a:bodyPr wrap="square" lIns="25400" tIns="25400" rIns="25400" bIns="25400" rtlCol="0" anchor="t">
+            <a:normAutofit fontScale="70000" lnSpcReduction="20000"/>
+          </a:bodyPr>
+          <a:lstStyle/>
+          <a:p>
+            <a:pPr marL="0" indent="0" algn="l">
+              <a:lnSpc>
+                <a:spcPct val="108000"/>
+              </a:lnSpc>
+              <a:buNone/>
+            </a:pPr>
+            <a:r>
+              <a:rPr lang="en-US" sz="5550" b="1" kern="0" spc="-111" dirty="0">
+                <a:solidFill>
+                  <a:srgbClr val="FFFFFF"/>
+                </a:solidFill>
+                <a:latin typeface="Arial" pitchFamily="34" charset="0"/>
+                <a:ea typeface="Arial" pitchFamily="34" charset="-122"/>
+                <a:cs typeface="Arial" pitchFamily="34" charset="-120"/>
+              </a:rPr>
+              <a:t>DISTILLATION AND FINE TUNING YOUR OWN </a:t>
+            </a:r>
+            <a:r>
+              <a:rPr lang="en-US" sz="5550" i="1" kern="0" spc="-111" dirty="0">
+                <a:solidFill>
+                  <a:srgbClr val="EAAA00"/>
+                </a:solidFill>
+                <a:latin typeface="Arial" pitchFamily="34" charset="0"/>
+                <a:ea typeface="Arial" pitchFamily="34" charset="-122"/>
+                <a:cs typeface="Arial" pitchFamily="34" charset="-120"/>
+              </a:rPr>
+              <a:t>Student LLM</a:t>
+            </a:r>
+            <a:endParaRPr lang="en-US" sz="5550" dirty="0"/>
+          </a:p>
+        </p:txBody>
+      </p:sp>
+      <p:sp>
+        <p:nvSpPr>
+          <p:cNvPr id="7" name="Text 5">
+            <a:extLst>
+              <a:ext uri="{FF2B5EF4-FFF2-40B4-BE49-F238E27FC236}">
+                <a16:creationId xmlns:a16="http://schemas.microsoft.com/office/drawing/2014/main" id="{ACC92552-3088-83A3-705D-F1DB78B02AD9}"/>
+              </a:ext>
+            </a:extLst>
+          </p:cNvPr>
+          <p:cNvSpPr/>
+          <p:nvPr/>
+        </p:nvSpPr>
+        <p:spPr>
+          <a:xfrm>
+            <a:off x="838200" y="3761556"/>
+            <a:ext cx="7365957" cy="1109663"/>
+          </a:xfrm>
+          <a:prstGeom prst="rect">
+            <a:avLst/>
+          </a:prstGeom>
+          <a:noFill/>
+          <a:ln/>
+        </p:spPr>
+        <p:txBody>
+          <a:bodyPr wrap="square" lIns="25400" tIns="25400" rIns="25400" bIns="25400" rtlCol="0" anchor="t">
+            <a:normAutofit/>
+          </a:bodyPr>
+          <a:lstStyle/>
+          <a:p>
+            <a:pPr marL="0" indent="0" algn="l">
+              <a:lnSpc>
+                <a:spcPct val="150000"/>
+              </a:lnSpc>
+              <a:buNone/>
+            </a:pPr>
+            <a:r>
+              <a:rPr lang="en-US" sz="1875" dirty="0">
+                <a:solidFill>
+                  <a:srgbClr val="E7C9C5"/>
+                </a:solidFill>
+                <a:latin typeface="Arial" pitchFamily="34" charset="0"/>
+                <a:ea typeface="Arial" pitchFamily="34" charset="-122"/>
+                <a:cs typeface="Arial" pitchFamily="34" charset="-120"/>
+              </a:rPr>
+              <a:t>We would teach a small model to reason from a large one</a:t>
+            </a:r>
+            <a:endParaRPr lang="en-US" sz="1875" dirty="0"/>
+          </a:p>
+        </p:txBody>
+      </p:sp>
+      <p:sp>
+        <p:nvSpPr>
+          <p:cNvPr id="14" name="Shape 12">
+            <a:extLst>
+              <a:ext uri="{FF2B5EF4-FFF2-40B4-BE49-F238E27FC236}">
+                <a16:creationId xmlns:a16="http://schemas.microsoft.com/office/drawing/2014/main" id="{B986B34C-F465-D8C3-968C-8BE8A9A752A6}"/>
+              </a:ext>
+            </a:extLst>
+          </p:cNvPr>
+          <p:cNvSpPr/>
+          <p:nvPr/>
+        </p:nvSpPr>
+        <p:spPr>
+          <a:xfrm>
+            <a:off x="762000" y="6176963"/>
+            <a:ext cx="10668000" cy="9525"/>
+          </a:xfrm>
+          <a:prstGeom prst="rect">
+            <a:avLst/>
+          </a:prstGeom>
+          <a:solidFill>
+            <a:srgbClr val="FFFFFF">
+              <a:alpha val="12000"/>
+            </a:srgbClr>
+          </a:solidFill>
+          <a:ln/>
+        </p:spPr>
+        <p:txBody>
+          <a:bodyPr/>
+          <a:lstStyle/>
+          <a:p>
+            <a:endParaRPr lang="en-US"/>
+          </a:p>
+        </p:txBody>
+      </p:sp>
+      <p:sp>
+        <p:nvSpPr>
+          <p:cNvPr id="15" name="Text 13">
+            <a:extLst>
+              <a:ext uri="{FF2B5EF4-FFF2-40B4-BE49-F238E27FC236}">
+                <a16:creationId xmlns:a16="http://schemas.microsoft.com/office/drawing/2014/main" id="{6BFB3991-787E-93C1-2D49-0E6C98EF9715}"/>
+              </a:ext>
+            </a:extLst>
+          </p:cNvPr>
+          <p:cNvSpPr/>
+          <p:nvPr/>
+        </p:nvSpPr>
+        <p:spPr>
+          <a:xfrm>
+            <a:off x="762000" y="6319838"/>
+            <a:ext cx="2527995" cy="252413"/>
+          </a:xfrm>
+          <a:prstGeom prst="rect">
+            <a:avLst/>
+          </a:prstGeom>
+          <a:noFill/>
+          <a:ln/>
+        </p:spPr>
+        <p:txBody>
+          <a:bodyPr wrap="square" lIns="25400" tIns="25400" rIns="25400" bIns="25400" rtlCol="0" anchor="t">
+            <a:normAutofit fontScale="92500" lnSpcReduction="10000"/>
+          </a:bodyPr>
+          <a:lstStyle/>
+          <a:p>
+            <a:pPr marL="0" indent="0" algn="l">
+              <a:lnSpc>
+                <a:spcPct val="150000"/>
+              </a:lnSpc>
+              <a:buNone/>
+            </a:pPr>
+            <a:r>
+              <a:rPr lang="en-US" sz="1125" kern="0" spc="68" dirty="0">
+                <a:solidFill>
+                  <a:srgbClr val="EAAA00"/>
+                </a:solidFill>
+                <a:latin typeface="IBM Plex Mono" pitchFamily="34" charset="0"/>
+                <a:ea typeface="IBM Plex Mono" pitchFamily="34" charset="-122"/>
+                <a:cs typeface="IBM Plex Mono" pitchFamily="34" charset="-120"/>
+              </a:rPr>
+              <a:t>UChicago PME · AI Training</a:t>
+            </a:r>
+            <a:endParaRPr lang="en-US" sz="1125" dirty="0"/>
+          </a:p>
+        </p:txBody>
+      </p:sp>
+      <p:sp>
+        <p:nvSpPr>
+          <p:cNvPr id="16" name="Text 14">
+            <a:extLst>
+              <a:ext uri="{FF2B5EF4-FFF2-40B4-BE49-F238E27FC236}">
+                <a16:creationId xmlns:a16="http://schemas.microsoft.com/office/drawing/2014/main" id="{DF7F33C9-431C-FAEE-9184-0A69F82EC08B}"/>
+              </a:ext>
+            </a:extLst>
+          </p:cNvPr>
+          <p:cNvSpPr/>
+          <p:nvPr/>
+        </p:nvSpPr>
+        <p:spPr>
+          <a:xfrm>
+            <a:off x="8978205" y="6319838"/>
+            <a:ext cx="2527995" cy="252413"/>
+          </a:xfrm>
+          <a:prstGeom prst="rect">
+            <a:avLst/>
+          </a:prstGeom>
+          <a:noFill/>
+          <a:ln/>
+        </p:spPr>
+        <p:txBody>
+          <a:bodyPr wrap="square" lIns="25400" tIns="25400" rIns="25400" bIns="25400" rtlCol="0" anchor="t">
+            <a:normAutofit fontScale="92500" lnSpcReduction="10000"/>
+          </a:bodyPr>
+          <a:lstStyle/>
+          <a:p>
+            <a:pPr marL="0" indent="0" algn="l">
+              <a:lnSpc>
+                <a:spcPct val="150000"/>
+              </a:lnSpc>
+              <a:buNone/>
+            </a:pPr>
+            <a:r>
+              <a:rPr lang="en-US" sz="1125" kern="0" spc="68" dirty="0">
+                <a:solidFill>
+                  <a:srgbClr val="B3756F"/>
+                </a:solidFill>
+                <a:latin typeface="IBM Plex Mono" pitchFamily="34" charset="0"/>
+                <a:ea typeface="IBM Plex Mono" pitchFamily="34" charset="-122"/>
+                <a:cs typeface="IBM Plex Mono" pitchFamily="34" charset="-120"/>
+              </a:rPr>
+              <a:t>Module 2b — Multimodal PDF</a:t>
+            </a:r>
+            <a:endParaRPr lang="en-US" sz="1125" dirty="0"/>
+          </a:p>
+        </p:txBody>
+      </p:sp>
+    </p:spTree>
+    <p:extLst>
+      <p:ext uri="{BB962C8B-B14F-4D97-AF65-F5344CB8AC3E}">
+        <p14:creationId xmlns:p14="http://schemas.microsoft.com/office/powerpoint/2010/main" val="3211190761"/>
+      </p:ext>
+    </p:extLst>
+  </p:cSld>
+  <p:clrMapOvr>
+    <a:masterClrMapping/>
+  </p:clrMapOvr>
+</p:sld>
+</file>
+
+<file path=ppt/slides/slide19.xml><?xml version="1.0" encoding="utf-8"?>
+<p:sld xmlns:a="http://schemas.openxmlformats.org/drawingml/2006/main" xmlns:r="http://schemas.openxmlformats.org/officeDocument/2006/relationships" xmlns:p="http://schemas.openxmlformats.org/presentationml/2006/main">
+  <p:cSld>
+    <p:spTree>
+      <p:nvGrpSpPr>
+        <p:cNvPr id="1" name="">
+          <a:extLst>
+            <a:ext uri="{FF2B5EF4-FFF2-40B4-BE49-F238E27FC236}">
+              <a16:creationId xmlns:a16="http://schemas.microsoft.com/office/drawing/2014/main" id="{315941D5-F895-7FFF-E60C-FA1BEA67948A}"/>
+            </a:ext>
+          </a:extLst>
+        </p:cNvPr>
+        <p:cNvGrpSpPr/>
+        <p:nvPr/>
+      </p:nvGrpSpPr>
+      <p:grpSpPr>
+        <a:xfrm>
+          <a:off x="0" y="0"/>
+          <a:ext cx="0" cy="0"/>
+          <a:chOff x="0" y="0"/>
+          <a:chExt cx="0" cy="0"/>
+        </a:xfrm>
+      </p:grpSpPr>
+      <p:sp>
+        <p:nvSpPr>
+          <p:cNvPr id="2" name="Shape 0">
+            <a:extLst>
+              <a:ext uri="{FF2B5EF4-FFF2-40B4-BE49-F238E27FC236}">
+                <a16:creationId xmlns:a16="http://schemas.microsoft.com/office/drawing/2014/main" id="{1C211D5C-DBDC-E9B7-189D-195205FB6503}"/>
+              </a:ext>
+            </a:extLst>
+          </p:cNvPr>
+          <p:cNvSpPr/>
+          <p:nvPr/>
+        </p:nvSpPr>
+        <p:spPr>
+          <a:xfrm>
+            <a:off x="0" y="0"/>
+            <a:ext cx="12192000" cy="6858000"/>
+          </a:xfrm>
+          <a:prstGeom prst="rect">
+            <a:avLst/>
+          </a:prstGeom>
+          <a:solidFill>
+            <a:srgbClr val="FFFFFF"/>
+          </a:solidFill>
+          <a:ln/>
+        </p:spPr>
+        <p:txBody>
+          <a:bodyPr/>
+          <a:lstStyle/>
+          <a:p>
+            <a:endParaRPr lang="en-US"/>
+          </a:p>
+        </p:txBody>
+      </p:sp>
+      <p:sp>
+        <p:nvSpPr>
+          <p:cNvPr id="3" name="Text 1">
+            <a:extLst>
+              <a:ext uri="{FF2B5EF4-FFF2-40B4-BE49-F238E27FC236}">
+                <a16:creationId xmlns:a16="http://schemas.microsoft.com/office/drawing/2014/main" id="{9C902227-8604-AA11-62E7-9EACFF20B9AC}"/>
+              </a:ext>
+            </a:extLst>
+          </p:cNvPr>
+          <p:cNvSpPr/>
+          <p:nvPr/>
+        </p:nvSpPr>
+        <p:spPr>
+          <a:xfrm>
+            <a:off x="762000" y="1033909"/>
+            <a:ext cx="1218084" cy="261937"/>
+          </a:xfrm>
+          <a:prstGeom prst="rect">
+            <a:avLst/>
+          </a:prstGeom>
+          <a:noFill/>
+          <a:ln/>
+        </p:spPr>
+        <p:txBody>
+          <a:bodyPr wrap="square" lIns="0" tIns="0" rIns="0" bIns="0" rtlCol="0" anchor="t">
+            <a:normAutofit lnSpcReduction="10000"/>
+          </a:bodyPr>
+          <a:lstStyle/>
+          <a:p>
+            <a:pPr marL="0" indent="0" algn="l">
+              <a:lnSpc>
+                <a:spcPct val="150000"/>
+              </a:lnSpc>
+              <a:buNone/>
+            </a:pPr>
+            <a:r>
+              <a:rPr lang="en-US" sz="1350" kern="0" spc="189" dirty="0">
+                <a:solidFill>
+                  <a:srgbClr val="800000"/>
+                </a:solidFill>
+                <a:latin typeface="IBM Plex Mono" pitchFamily="34" charset="0"/>
+                <a:ea typeface="IBM Plex Mono" pitchFamily="34" charset="-122"/>
+                <a:cs typeface="IBM Plex Mono" pitchFamily="34" charset="-120"/>
+              </a:rPr>
+              <a:t>MODULE 3</a:t>
+            </a:r>
+            <a:endParaRPr lang="en-US" sz="1350" dirty="0"/>
+          </a:p>
+        </p:txBody>
+      </p:sp>
+      <p:sp>
+        <p:nvSpPr>
+          <p:cNvPr id="4" name="Text 2">
+            <a:extLst>
+              <a:ext uri="{FF2B5EF4-FFF2-40B4-BE49-F238E27FC236}">
+                <a16:creationId xmlns:a16="http://schemas.microsoft.com/office/drawing/2014/main" id="{4B3E5D7C-2339-FC31-18F6-13A453473879}"/>
+              </a:ext>
+            </a:extLst>
+          </p:cNvPr>
+          <p:cNvSpPr/>
+          <p:nvPr/>
+        </p:nvSpPr>
+        <p:spPr>
+          <a:xfrm>
+            <a:off x="2018184" y="1019621"/>
+            <a:ext cx="2233092" cy="295275"/>
+          </a:xfrm>
+          <a:prstGeom prst="rect">
+            <a:avLst/>
+          </a:prstGeom>
+          <a:noFill/>
+          <a:ln/>
+        </p:spPr>
+        <p:txBody>
+          <a:bodyPr wrap="square" lIns="25400" tIns="25400" rIns="25400" bIns="25400" rtlCol="0" anchor="t">
+            <a:normAutofit fontScale="92500" lnSpcReduction="10000"/>
+          </a:bodyPr>
+          <a:lstStyle/>
+          <a:p>
+            <a:pPr marL="0" indent="0" algn="l">
+              <a:lnSpc>
+                <a:spcPct val="150000"/>
+              </a:lnSpc>
+              <a:buNone/>
+            </a:pPr>
+            <a:r>
+              <a:rPr lang="en-US" sz="1350" kern="0" spc="189" dirty="0">
+                <a:solidFill>
+                  <a:srgbClr val="B07A00"/>
+                </a:solidFill>
+                <a:latin typeface="IBM Plex Mono" pitchFamily="34" charset="0"/>
+                <a:ea typeface="IBM Plex Mono" pitchFamily="34" charset="-122"/>
+                <a:cs typeface="IBM Plex Mono" pitchFamily="34" charset="-120"/>
+              </a:rPr>
+              <a:t>/ DISTILLATION</a:t>
+            </a:r>
+            <a:endParaRPr lang="en-US" sz="1350" dirty="0"/>
+          </a:p>
+        </p:txBody>
+      </p:sp>
+      <p:sp>
+        <p:nvSpPr>
+          <p:cNvPr id="5" name="Shape 3">
+            <a:extLst>
+              <a:ext uri="{FF2B5EF4-FFF2-40B4-BE49-F238E27FC236}">
+                <a16:creationId xmlns:a16="http://schemas.microsoft.com/office/drawing/2014/main" id="{E80F0E12-6C47-54A0-4D2D-9B734019D518}"/>
+              </a:ext>
+            </a:extLst>
+          </p:cNvPr>
+          <p:cNvSpPr/>
+          <p:nvPr/>
+        </p:nvSpPr>
+        <p:spPr>
+          <a:xfrm>
+            <a:off x="762000" y="1486346"/>
+            <a:ext cx="457200" cy="28575"/>
+          </a:xfrm>
+          <a:prstGeom prst="roundRect">
+            <a:avLst>
+              <a:gd name="adj" fmla="val 50000"/>
+            </a:avLst>
+          </a:prstGeom>
+          <a:solidFill>
+            <a:srgbClr val="800000"/>
+          </a:solidFill>
+          <a:ln/>
+        </p:spPr>
+        <p:txBody>
+          <a:bodyPr/>
+          <a:lstStyle/>
+          <a:p>
+            <a:endParaRPr lang="en-US"/>
+          </a:p>
+        </p:txBody>
+      </p:sp>
+      <p:sp>
+        <p:nvSpPr>
+          <p:cNvPr id="6" name="Text 4">
+            <a:extLst>
+              <a:ext uri="{FF2B5EF4-FFF2-40B4-BE49-F238E27FC236}">
+                <a16:creationId xmlns:a16="http://schemas.microsoft.com/office/drawing/2014/main" id="{727CC57C-C6DA-3620-6B01-061280B8CFF1}"/>
+              </a:ext>
+            </a:extLst>
+          </p:cNvPr>
+          <p:cNvSpPr/>
+          <p:nvPr/>
+        </p:nvSpPr>
+        <p:spPr>
+          <a:xfrm>
+            <a:off x="761999" y="1724470"/>
+            <a:ext cx="4514193" cy="831205"/>
+          </a:xfrm>
+          <a:prstGeom prst="rect">
+            <a:avLst/>
+          </a:prstGeom>
+          <a:noFill/>
+          <a:ln/>
+        </p:spPr>
+        <p:txBody>
+          <a:bodyPr wrap="square" lIns="25400" tIns="25400" rIns="25400" bIns="25400" rtlCol="0" anchor="t">
+            <a:normAutofit fontScale="55000" lnSpcReduction="20000"/>
+          </a:bodyPr>
+          <a:lstStyle/>
+          <a:p>
+            <a:pPr marL="0" indent="0" algn="l">
+              <a:lnSpc>
+                <a:spcPct val="108000"/>
+              </a:lnSpc>
+              <a:buNone/>
+            </a:pPr>
+            <a:r>
+              <a:rPr lang="en-US" sz="3450" b="1" kern="0" spc="-69" dirty="0">
+                <a:solidFill>
+                  <a:srgbClr val="1A1714"/>
+                </a:solidFill>
+                <a:latin typeface="Arial" pitchFamily="34" charset="0"/>
+                <a:ea typeface="Arial" pitchFamily="34" charset="-122"/>
+                <a:cs typeface="Arial" pitchFamily="34" charset="-120"/>
+              </a:rPr>
+              <a:t>Task: pick the better solvent for a compound (</a:t>
+            </a:r>
+            <a:r>
+              <a:rPr lang="en-US" sz="3450" b="1" kern="0" spc="-69" dirty="0" err="1">
+                <a:solidFill>
+                  <a:srgbClr val="1A1714"/>
+                </a:solidFill>
+                <a:latin typeface="Arial" pitchFamily="34" charset="0"/>
+                <a:ea typeface="Arial" pitchFamily="34" charset="-122"/>
+                <a:cs typeface="Arial" pitchFamily="34" charset="-120"/>
+              </a:rPr>
+              <a:t>solubench</a:t>
+            </a:r>
+            <a:r>
+              <a:rPr lang="en-US" sz="3450" b="1" kern="0" spc="-69" dirty="0">
+                <a:solidFill>
+                  <a:srgbClr val="1A1714"/>
+                </a:solidFill>
+                <a:latin typeface="Arial" pitchFamily="34" charset="0"/>
+                <a:ea typeface="Arial" pitchFamily="34" charset="-122"/>
+                <a:cs typeface="Arial" pitchFamily="34" charset="-120"/>
+              </a:rPr>
+              <a:t>, binary A/B, no reasoning given)</a:t>
+            </a:r>
+            <a:endParaRPr lang="en-US" sz="3450" dirty="0"/>
+          </a:p>
+        </p:txBody>
+      </p:sp>
+      <p:sp>
+        <p:nvSpPr>
+          <p:cNvPr id="11" name="Text 9">
+            <a:extLst>
+              <a:ext uri="{FF2B5EF4-FFF2-40B4-BE49-F238E27FC236}">
+                <a16:creationId xmlns:a16="http://schemas.microsoft.com/office/drawing/2014/main" id="{911923FB-83F4-729B-4254-521A60862245}"/>
+              </a:ext>
+            </a:extLst>
+          </p:cNvPr>
+          <p:cNvSpPr/>
+          <p:nvPr/>
+        </p:nvSpPr>
+        <p:spPr>
+          <a:xfrm>
+            <a:off x="762000" y="2593777"/>
+            <a:ext cx="4635474" cy="3449836"/>
+          </a:xfrm>
+          <a:prstGeom prst="rect">
+            <a:avLst/>
+          </a:prstGeom>
+          <a:noFill/>
+          <a:ln/>
+        </p:spPr>
+        <p:txBody>
+          <a:bodyPr wrap="square" lIns="25400" tIns="25400" rIns="25400" bIns="25400" rtlCol="0" anchor="t">
+            <a:normAutofit/>
+          </a:bodyPr>
+          <a:lstStyle/>
+          <a:p>
+            <a:pPr marL="285750" indent="-285750">
+              <a:buFont typeface="Arial" panose="020B0604020202020204" pitchFamily="34" charset="0"/>
+              <a:buChar char="•"/>
+            </a:pPr>
+            <a:r>
+              <a:rPr lang="en-US" b="1" dirty="0">
+                <a:latin typeface="Arial" panose="020B0604020202020204" pitchFamily="34" charset="0"/>
+                <a:cs typeface="Arial" panose="020B0604020202020204" pitchFamily="34" charset="0"/>
+              </a:rPr>
+              <a:t>Teacher</a:t>
+            </a:r>
+            <a:r>
+              <a:rPr lang="en-US" dirty="0">
+                <a:latin typeface="Arial" panose="020B0604020202020204" pitchFamily="34" charset="0"/>
+                <a:cs typeface="Arial" panose="020B0604020202020204" pitchFamily="34" charset="0"/>
+              </a:rPr>
+              <a:t> = DeepSeek v4-flash0731 writes the reasoning; </a:t>
+            </a:r>
+          </a:p>
+          <a:p>
+            <a:pPr marL="285750" indent="-285750">
+              <a:buFont typeface="Arial" panose="020B0604020202020204" pitchFamily="34" charset="0"/>
+              <a:buChar char="•"/>
+            </a:pPr>
+            <a:r>
+              <a:rPr lang="en-US" b="1" dirty="0">
+                <a:latin typeface="Arial" panose="020B0604020202020204" pitchFamily="34" charset="0"/>
+                <a:cs typeface="Arial" panose="020B0604020202020204" pitchFamily="34" charset="0"/>
+              </a:rPr>
+              <a:t>Student</a:t>
+            </a:r>
+            <a:r>
+              <a:rPr lang="en-US" dirty="0">
+                <a:latin typeface="Arial" panose="020B0604020202020204" pitchFamily="34" charset="0"/>
+                <a:cs typeface="Arial" panose="020B0604020202020204" pitchFamily="34" charset="0"/>
+              </a:rPr>
+              <a:t> = Qwen3-1.7B, </a:t>
+            </a:r>
+          </a:p>
+          <a:p>
+            <a:pPr marL="285750" indent="-285750">
+              <a:buFont typeface="Arial" panose="020B0604020202020204" pitchFamily="34" charset="0"/>
+              <a:buChar char="•"/>
+            </a:pPr>
+            <a:r>
+              <a:rPr lang="en-US" b="1" dirty="0">
+                <a:latin typeface="Arial" panose="020B0604020202020204" pitchFamily="34" charset="0"/>
+                <a:cs typeface="Arial" panose="020B0604020202020204" pitchFamily="34" charset="0"/>
+              </a:rPr>
+              <a:t>The trap</a:t>
+            </a:r>
+            <a:r>
+              <a:rPr lang="en-US" dirty="0">
+                <a:latin typeface="Arial" panose="020B0604020202020204" pitchFamily="34" charset="0"/>
+                <a:cs typeface="Arial" panose="020B0604020202020204" pitchFamily="34" charset="0"/>
+              </a:rPr>
+              <a:t>: show the teacher the answer → it rationalizes → student scores 0.41 </a:t>
+            </a:r>
+          </a:p>
+          <a:p>
+            <a:pPr marL="285750" indent="-285750">
+              <a:buFont typeface="Arial" panose="020B0604020202020204" pitchFamily="34" charset="0"/>
+              <a:buChar char="•"/>
+            </a:pPr>
+            <a:r>
+              <a:rPr lang="en-US" b="1" dirty="0">
+                <a:latin typeface="Arial" panose="020B0604020202020204" pitchFamily="34" charset="0"/>
+                <a:cs typeface="Arial" panose="020B0604020202020204" pitchFamily="34" charset="0"/>
+              </a:rPr>
+              <a:t>The correct way</a:t>
+            </a:r>
+            <a:r>
+              <a:rPr lang="en-US" dirty="0">
+                <a:latin typeface="Arial" panose="020B0604020202020204" pitchFamily="34" charset="0"/>
+                <a:cs typeface="Arial" panose="020B0604020202020204" pitchFamily="34" charset="0"/>
+              </a:rPr>
+              <a:t>: teacher answers blind, keep only the chains it gets right → 2114 real derivations</a:t>
+            </a:r>
+          </a:p>
+          <a:p>
+            <a:pPr marL="285750" indent="-285750">
+              <a:buFont typeface="Arial" panose="020B0604020202020204" pitchFamily="34" charset="0"/>
+              <a:buChar char="•"/>
+            </a:pPr>
+            <a:r>
+              <a:rPr lang="en-US" b="1" dirty="0">
+                <a:latin typeface="Arial" panose="020B0604020202020204" pitchFamily="34" charset="0"/>
+                <a:cs typeface="Arial" panose="020B0604020202020204" pitchFamily="34" charset="0"/>
+              </a:rPr>
+              <a:t>Test Set Result</a:t>
+            </a:r>
+            <a:r>
+              <a:rPr lang="en-US" dirty="0">
+                <a:latin typeface="Arial" panose="020B0604020202020204" pitchFamily="34" charset="0"/>
+                <a:cs typeface="Arial" panose="020B0604020202020204" pitchFamily="34" charset="0"/>
+              </a:rPr>
+              <a:t>: student 0.01 → 0.825, matching the teacher's own 0.846 accuracy indicating real capability transfer</a:t>
+            </a:r>
+          </a:p>
+          <a:p>
+            <a:endParaRPr lang="en-US" dirty="0">
+              <a:latin typeface="Arial" panose="020B0604020202020204" pitchFamily="34" charset="0"/>
+              <a:cs typeface="Arial" panose="020B0604020202020204" pitchFamily="34" charset="0"/>
+            </a:endParaRPr>
+          </a:p>
+        </p:txBody>
+      </p:sp>
+      <p:sp>
+        <p:nvSpPr>
+          <p:cNvPr id="12" name="Shape 10">
+            <a:extLst>
+              <a:ext uri="{FF2B5EF4-FFF2-40B4-BE49-F238E27FC236}">
+                <a16:creationId xmlns:a16="http://schemas.microsoft.com/office/drawing/2014/main" id="{121CB4C1-6F05-9FD4-5A97-681882179856}"/>
+              </a:ext>
+            </a:extLst>
+          </p:cNvPr>
+          <p:cNvSpPr/>
+          <p:nvPr/>
+        </p:nvSpPr>
+        <p:spPr>
+          <a:xfrm>
+            <a:off x="5397475" y="1109663"/>
+            <a:ext cx="6032525" cy="4095750"/>
+          </a:xfrm>
+          <a:prstGeom prst="roundRect">
+            <a:avLst>
+              <a:gd name="adj" fmla="val 2791"/>
+            </a:avLst>
+          </a:prstGeom>
+          <a:solidFill>
+            <a:srgbClr val="FFFFFF"/>
+          </a:solidFill>
+          <a:ln w="9525">
+            <a:solidFill>
+              <a:srgbClr val="E8E3DB"/>
+            </a:solidFill>
+            <a:prstDash val="solid"/>
+          </a:ln>
+          <a:effectLst>
+            <a:outerShdw blurRad="114300" dist="38100" dir="5400000" algn="bl" rotWithShape="0">
+              <a:srgbClr val="1A1714">
+                <a:alpha val="8000"/>
+              </a:srgbClr>
+            </a:outerShdw>
+          </a:effectLst>
+        </p:spPr>
+        <p:txBody>
+          <a:bodyPr/>
+          <a:lstStyle/>
+          <a:p>
+            <a:endParaRPr lang="en-US"/>
+          </a:p>
+        </p:txBody>
+      </p:sp>
+      <p:sp>
+        <p:nvSpPr>
+          <p:cNvPr id="16" name="Shape 13">
+            <a:extLst>
+              <a:ext uri="{FF2B5EF4-FFF2-40B4-BE49-F238E27FC236}">
+                <a16:creationId xmlns:a16="http://schemas.microsoft.com/office/drawing/2014/main" id="{2FD24BF8-C118-235F-0BB0-445A3B543D0B}"/>
+              </a:ext>
+            </a:extLst>
+          </p:cNvPr>
+          <p:cNvSpPr/>
+          <p:nvPr/>
+        </p:nvSpPr>
+        <p:spPr>
+          <a:xfrm>
+            <a:off x="762000" y="6176963"/>
+            <a:ext cx="10668000" cy="9525"/>
+          </a:xfrm>
+          <a:prstGeom prst="rect">
+            <a:avLst/>
+          </a:prstGeom>
+          <a:solidFill>
+            <a:srgbClr val="E8E3DB"/>
+          </a:solidFill>
+          <a:ln/>
+        </p:spPr>
+        <p:txBody>
+          <a:bodyPr/>
+          <a:lstStyle/>
+          <a:p>
+            <a:endParaRPr lang="en-US"/>
+          </a:p>
+        </p:txBody>
+      </p:sp>
+      <p:sp>
+        <p:nvSpPr>
+          <p:cNvPr id="17" name="Text 14">
+            <a:extLst>
+              <a:ext uri="{FF2B5EF4-FFF2-40B4-BE49-F238E27FC236}">
+                <a16:creationId xmlns:a16="http://schemas.microsoft.com/office/drawing/2014/main" id="{C349AD57-5604-BBD0-FE22-D6DA15C249C9}"/>
+              </a:ext>
+            </a:extLst>
+          </p:cNvPr>
+          <p:cNvSpPr/>
+          <p:nvPr/>
+        </p:nvSpPr>
+        <p:spPr>
+          <a:xfrm>
+            <a:off x="762000" y="6319838"/>
+            <a:ext cx="2527995" cy="252413"/>
+          </a:xfrm>
+          <a:prstGeom prst="rect">
+            <a:avLst/>
+          </a:prstGeom>
+          <a:noFill/>
+          <a:ln/>
+        </p:spPr>
+        <p:txBody>
+          <a:bodyPr wrap="square" lIns="25400" tIns="25400" rIns="25400" bIns="25400" rtlCol="0" anchor="t">
+            <a:normAutofit fontScale="92500" lnSpcReduction="10000"/>
+          </a:bodyPr>
+          <a:lstStyle/>
+          <a:p>
+            <a:pPr marL="0" indent="0" algn="l">
+              <a:lnSpc>
+                <a:spcPct val="150000"/>
+              </a:lnSpc>
+              <a:buNone/>
+            </a:pPr>
+            <a:r>
+              <a:rPr lang="en-US" sz="1125" kern="0" spc="68" dirty="0">
+                <a:solidFill>
+                  <a:srgbClr val="800000"/>
+                </a:solidFill>
+                <a:latin typeface="IBM Plex Mono" pitchFamily="34" charset="0"/>
+                <a:ea typeface="IBM Plex Mono" pitchFamily="34" charset="-122"/>
+                <a:cs typeface="IBM Plex Mono" pitchFamily="34" charset="-120"/>
+              </a:rPr>
+              <a:t>UChicago PME · AI Training</a:t>
+            </a:r>
+            <a:endParaRPr lang="en-US" sz="1125" dirty="0"/>
+          </a:p>
+        </p:txBody>
+      </p:sp>
+      <p:sp>
+        <p:nvSpPr>
+          <p:cNvPr id="18" name="Text 15">
+            <a:extLst>
+              <a:ext uri="{FF2B5EF4-FFF2-40B4-BE49-F238E27FC236}">
+                <a16:creationId xmlns:a16="http://schemas.microsoft.com/office/drawing/2014/main" id="{6A318362-2863-F984-AAA2-456A36DBC63D}"/>
+              </a:ext>
+            </a:extLst>
+          </p:cNvPr>
+          <p:cNvSpPr/>
+          <p:nvPr/>
+        </p:nvSpPr>
+        <p:spPr>
+          <a:xfrm>
+            <a:off x="8978205" y="6319838"/>
+            <a:ext cx="2527995" cy="252413"/>
+          </a:xfrm>
+          <a:prstGeom prst="rect">
+            <a:avLst/>
+          </a:prstGeom>
+          <a:noFill/>
+          <a:ln/>
+        </p:spPr>
+        <p:txBody>
+          <a:bodyPr wrap="square" lIns="25400" tIns="25400" rIns="25400" bIns="25400" rtlCol="0" anchor="t">
+            <a:normAutofit fontScale="92500" lnSpcReduction="10000"/>
+          </a:bodyPr>
+          <a:lstStyle/>
+          <a:p>
+            <a:pPr marL="0" indent="0" algn="l">
+              <a:lnSpc>
+                <a:spcPct val="150000"/>
+              </a:lnSpc>
+              <a:buNone/>
+            </a:pPr>
+            <a:r>
+              <a:rPr lang="en-US" sz="1125" kern="0" spc="68" dirty="0">
+                <a:solidFill>
+                  <a:srgbClr val="938A80"/>
+                </a:solidFill>
+                <a:latin typeface="IBM Plex Mono" pitchFamily="34" charset="0"/>
+                <a:ea typeface="IBM Plex Mono" pitchFamily="34" charset="-122"/>
+                <a:cs typeface="IBM Plex Mono" pitchFamily="34" charset="-120"/>
+              </a:rPr>
+              <a:t>Module 3 — DISTILLATION</a:t>
+            </a:r>
+            <a:endParaRPr lang="en-US" sz="1125" dirty="0"/>
+          </a:p>
+        </p:txBody>
+      </p:sp>
+      <p:pic>
+        <p:nvPicPr>
+          <p:cNvPr id="13" name="Picture 12">
+            <a:extLst>
+              <a:ext uri="{FF2B5EF4-FFF2-40B4-BE49-F238E27FC236}">
+                <a16:creationId xmlns:a16="http://schemas.microsoft.com/office/drawing/2014/main" id="{45F7B965-F99A-CE9E-58CC-7941CD407C24}"/>
+              </a:ext>
+            </a:extLst>
+          </p:cNvPr>
+          <p:cNvPicPr>
+            <a:picLocks noChangeAspect="1"/>
+          </p:cNvPicPr>
+          <p:nvPr/>
+        </p:nvPicPr>
+        <p:blipFill>
+          <a:blip r:embed="rId3"/>
+          <a:stretch>
+            <a:fillRect/>
+          </a:stretch>
+        </p:blipFill>
+        <p:spPr>
+          <a:xfrm>
+            <a:off x="6324587" y="1400175"/>
+            <a:ext cx="4178300" cy="3733800"/>
+          </a:xfrm>
+          <a:prstGeom prst="rect">
+            <a:avLst/>
+          </a:prstGeom>
+        </p:spPr>
+      </p:pic>
+      <p:pic>
+        <p:nvPicPr>
+          <p:cNvPr id="14" name="Picture 13" descr="DeepSeek Logo and symbol, meaning, history, PNG, brand">
+            <a:extLst>
+              <a:ext uri="{FF2B5EF4-FFF2-40B4-BE49-F238E27FC236}">
+                <a16:creationId xmlns:a16="http://schemas.microsoft.com/office/drawing/2014/main" id="{3E2D12D5-0306-8FC2-7359-B388855F5BF8}"/>
+              </a:ext>
+            </a:extLst>
+          </p:cNvPr>
+          <p:cNvPicPr>
+            <a:picLocks noChangeAspect="1"/>
+          </p:cNvPicPr>
+          <p:nvPr/>
+        </p:nvPicPr>
+        <p:blipFill>
+          <a:blip r:embed="rId4"/>
+          <a:stretch>
+            <a:fillRect/>
+          </a:stretch>
+        </p:blipFill>
+        <p:spPr>
+          <a:xfrm>
+            <a:off x="10110925" y="1823530"/>
+            <a:ext cx="1125483" cy="633084"/>
+          </a:xfrm>
+          <a:prstGeom prst="rect">
+            <a:avLst/>
+          </a:prstGeom>
+        </p:spPr>
+      </p:pic>
+      <p:pic>
+        <p:nvPicPr>
+          <p:cNvPr id="19" name="Picture 18" descr="Logos Download | Qwen">
+            <a:extLst>
+              <a:ext uri="{FF2B5EF4-FFF2-40B4-BE49-F238E27FC236}">
+                <a16:creationId xmlns:a16="http://schemas.microsoft.com/office/drawing/2014/main" id="{AB15AF88-0301-AC12-B42D-668EEA32C0D0}"/>
+              </a:ext>
+            </a:extLst>
+          </p:cNvPr>
+          <p:cNvPicPr>
+            <a:picLocks noChangeAspect="1"/>
+          </p:cNvPicPr>
+          <p:nvPr/>
+        </p:nvPicPr>
+        <p:blipFill>
+          <a:blip r:embed="rId5"/>
+          <a:stretch>
+            <a:fillRect/>
+          </a:stretch>
+        </p:blipFill>
+        <p:spPr>
+          <a:xfrm>
+            <a:off x="10171814" y="2452493"/>
+            <a:ext cx="1003704" cy="293991"/>
+          </a:xfrm>
+          <a:prstGeom prst="rect">
+            <a:avLst/>
+          </a:prstGeom>
+        </p:spPr>
+      </p:pic>
+    </p:spTree>
+    <p:extLst>
+      <p:ext uri="{BB962C8B-B14F-4D97-AF65-F5344CB8AC3E}">
+        <p14:creationId xmlns:p14="http://schemas.microsoft.com/office/powerpoint/2010/main" val="953344492"/>
+      </p:ext>
+    </p:extLst>
   </p:cSld>
   <p:clrMapOvr>
     <a:masterClrMapping/>
@@ -9200,7 +12182,7 @@
         </p:spPr>
         <p:txBody>
           <a:bodyPr wrap="square" lIns="25400" tIns="25400" rIns="25400" bIns="25400" rtlCol="0" anchor="t">
-            <a:normAutofit fontScale="92500" lnSpcReduction="20000"/>
+            <a:normAutofit fontScale="85000" lnSpcReduction="10000"/>
           </a:bodyPr>
           <a:lstStyle/>
           <a:p>
@@ -9219,7 +12201,40 @@
                 <a:ea typeface="Arial" pitchFamily="34" charset="-122"/>
                 <a:cs typeface="Arial" pitchFamily="34" charset="-120"/>
               </a:rPr>
-              <a:t>The model lineup, scored honestly</a:t>
+              <a:t>The models</a:t>
+            </a:r>
+            <a:r>
+              <a:rPr lang="zh-CN" altLang="en-US" sz="3450" b="1" kern="0" spc="-69" dirty="0">
+                <a:solidFill>
+                  <a:srgbClr val="1A1714"/>
+                </a:solidFill>
+                <a:latin typeface="Arial" pitchFamily="34" charset="0"/>
+                <a:ea typeface="Arial" pitchFamily="34" charset="-122"/>
+                <a:cs typeface="Arial" pitchFamily="34" charset="-120"/>
+              </a:rPr>
+              <a:t>’ </a:t>
+            </a:r>
+            <a:r>
+              <a:rPr lang="en-US" altLang="zh-CN" sz="3450" b="1" kern="0" spc="-69" dirty="0">
+                <a:solidFill>
+                  <a:srgbClr val="1A1714"/>
+                </a:solidFill>
+                <a:latin typeface="Arial" pitchFamily="34" charset="0"/>
+                <a:ea typeface="Arial" pitchFamily="34" charset="-122"/>
+                <a:cs typeface="Arial" pitchFamily="34" charset="-120"/>
+              </a:rPr>
+              <a:t>predicting</a:t>
+            </a:r>
+            <a:r>
+              <a:rPr lang="en-US" sz="3450" b="1" kern="0" spc="-69" dirty="0">
+                <a:solidFill>
+                  <a:srgbClr val="1A1714"/>
+                </a:solidFill>
+                <a:latin typeface="Arial" pitchFamily="34" charset="0"/>
+                <a:ea typeface="Arial" pitchFamily="34" charset="-122"/>
+                <a:cs typeface="Arial" pitchFamily="34" charset="-120"/>
+              </a:rPr>
+              <a:t> performances</a:t>
             </a:r>
             <a:endParaRPr lang="en-US" sz="3450" dirty="0"/>
           </a:p>
@@ -12169,18 +15184,16 @@
 
 <file path=ppt/slides/slide9.xml><?xml version="1.0" encoding="utf-8"?>
 <p:sld xmlns:a="http://schemas.openxmlformats.org/drawingml/2006/main" xmlns:r="http://schemas.openxmlformats.org/officeDocument/2006/relationships" xmlns:p="http://schemas.openxmlformats.org/presentationml/2006/main">
-  <p:cSld name="Slide 9">
-    <p:bg>
-      <p:bgPr>
-        <a:solidFill>
-          <a:srgbClr val="1A1714"/>
-        </a:solidFill>
-        <a:effectLst/>
-      </p:bgPr>
-    </p:bg>
+  <p:cSld>
     <p:spTree>
       <p:nvGrpSpPr>
-        <p:cNvPr id="1" name=""/>
+        <p:cNvPr id="1" name="">
+          <a:extLst>
+            <a:ext uri="{FF2B5EF4-FFF2-40B4-BE49-F238E27FC236}">
+              <a16:creationId xmlns:a16="http://schemas.microsoft.com/office/drawing/2014/main" id="{0484274D-153A-677A-A80D-B7832808B0DB}"/>
+            </a:ext>
+          </a:extLst>
+        </p:cNvPr>
         <p:cNvGrpSpPr/>
         <p:nvPr/>
       </p:nvGrpSpPr>
@@ -12194,7 +15207,13 @@
       </p:grpSpPr>
       <p:sp>
         <p:nvSpPr>
-          <p:cNvPr id="2" name="Shape 0"/>
+          <p:cNvPr id="2" name="Shape 0">
+            <a:extLst>
+              <a:ext uri="{FF2B5EF4-FFF2-40B4-BE49-F238E27FC236}">
+                <a16:creationId xmlns:a16="http://schemas.microsoft.com/office/drawing/2014/main" id="{329250E7-D54D-FE29-5F1C-5D50DD58C86E}"/>
+              </a:ext>
+            </a:extLst>
+          </p:cNvPr>
           <p:cNvSpPr/>
           <p:nvPr/>
         </p:nvSpPr>
@@ -12221,7 +15240,13 @@
       </p:sp>
       <p:sp>
         <p:nvSpPr>
-          <p:cNvPr id="3" name="Text 1"/>
+          <p:cNvPr id="3" name="Text 1">
+            <a:extLst>
+              <a:ext uri="{FF2B5EF4-FFF2-40B4-BE49-F238E27FC236}">
+                <a16:creationId xmlns:a16="http://schemas.microsoft.com/office/drawing/2014/main" id="{DC39989B-AD6E-24C2-CB2A-51386E6D5413}"/>
+              </a:ext>
+            </a:extLst>
+          </p:cNvPr>
           <p:cNvSpPr/>
           <p:nvPr/>
         </p:nvSpPr>
@@ -12257,7 +15282,7 @@
                 <a:ea typeface="IBM Plex Mono" pitchFamily="34" charset="-122"/>
                 <a:cs typeface="IBM Plex Mono" pitchFamily="34" charset="-120"/>
               </a:rPr>
-              <a:t>MODULE 2A</a:t>
+              <a:t>MODULE 1C</a:t>
             </a:r>
             <a:endParaRPr lang="en-US" sz="1350" dirty="0"/>
           </a:p>
@@ -12265,14 +15290,20 @@
       </p:sp>
       <p:sp>
         <p:nvSpPr>
-          <p:cNvPr id="4" name="Text 2"/>
+          <p:cNvPr id="4" name="Text 2">
+            <a:extLst>
+              <a:ext uri="{FF2B5EF4-FFF2-40B4-BE49-F238E27FC236}">
+                <a16:creationId xmlns:a16="http://schemas.microsoft.com/office/drawing/2014/main" id="{0CABA208-21B8-E5BA-3F5D-EC91D75C93CB}"/>
+              </a:ext>
+            </a:extLst>
+          </p:cNvPr>
           <p:cNvSpPr/>
           <p:nvPr/>
         </p:nvSpPr>
         <p:spPr>
           <a:xfrm>
             <a:off x="2094384" y="1267644"/>
-            <a:ext cx="2106588" cy="295275"/>
+            <a:ext cx="3136374" cy="295275"/>
           </a:xfrm>
           <a:prstGeom prst="rect">
             <a:avLst/>
@@ -12301,7 +15332,7 @@
                 <a:ea typeface="IBM Plex Mono" pitchFamily="34" charset="-122"/>
                 <a:cs typeface="IBM Plex Mono" pitchFamily="34" charset="-120"/>
               </a:rPr>
-              <a:t>/ TEXT → DATASET</a:t>
+              <a:t>/ DATASET GALLERY</a:t>
             </a:r>
             <a:endParaRPr lang="en-US" sz="1350" dirty="0"/>
           </a:p>
@@ -12309,7 +15340,13 @@
       </p:sp>
       <p:sp>
         <p:nvSpPr>
-          <p:cNvPr id="5" name="Shape 3"/>
+          <p:cNvPr id="5" name="Shape 3">
+            <a:extLst>
+              <a:ext uri="{FF2B5EF4-FFF2-40B4-BE49-F238E27FC236}">
+                <a16:creationId xmlns:a16="http://schemas.microsoft.com/office/drawing/2014/main" id="{F4F53C16-C373-501B-46F5-BEE5006E89E5}"/>
+              </a:ext>
+            </a:extLst>
+          </p:cNvPr>
           <p:cNvSpPr/>
           <p:nvPr/>
         </p:nvSpPr>
@@ -12338,14 +15375,20 @@
       </p:sp>
       <p:sp>
         <p:nvSpPr>
-          <p:cNvPr id="6" name="Text 4"/>
+          <p:cNvPr id="6" name="Text 4">
+            <a:extLst>
+              <a:ext uri="{FF2B5EF4-FFF2-40B4-BE49-F238E27FC236}">
+                <a16:creationId xmlns:a16="http://schemas.microsoft.com/office/drawing/2014/main" id="{90C0923A-76D8-784B-0CD2-2D1E15DA2F3C}"/>
+              </a:ext>
+            </a:extLst>
+          </p:cNvPr>
           <p:cNvSpPr/>
           <p:nvPr/>
         </p:nvSpPr>
         <p:spPr>
           <a:xfrm>
             <a:off x="838200" y="1972494"/>
-            <a:ext cx="6863923" cy="1560463"/>
+            <a:ext cx="7267696" cy="1560463"/>
           </a:xfrm>
           <a:prstGeom prst="rect">
             <a:avLst/>
@@ -12374,7 +15417,7 @@
                 <a:ea typeface="Arial" pitchFamily="34" charset="-122"/>
                 <a:cs typeface="Arial" pitchFamily="34" charset="-120"/>
               </a:rPr>
-              <a:t>From papers to a </a:t>
+              <a:t>One pipeline, </a:t>
             </a:r>
             <a:r>
               <a:rPr lang="en-US" sz="5550" i="1" kern="0" spc="-111" dirty="0">
@@ -12385,7 +15428,7 @@
                 <a:ea typeface="Arial" pitchFamily="34" charset="-122"/>
                 <a:cs typeface="Arial" pitchFamily="34" charset="-120"/>
               </a:rPr>
-              <a:t>clean dataset</a:t>
+              <a:t>five domains</a:t>
             </a:r>
             <a:endParaRPr lang="en-US" sz="5550" dirty="0"/>
           </a:p>
@@ -12393,14 +15436,20 @@
       </p:sp>
       <p:sp>
         <p:nvSpPr>
-          <p:cNvPr id="7" name="Text 5"/>
+          <p:cNvPr id="7" name="Text 5">
+            <a:extLst>
+              <a:ext uri="{FF2B5EF4-FFF2-40B4-BE49-F238E27FC236}">
+                <a16:creationId xmlns:a16="http://schemas.microsoft.com/office/drawing/2014/main" id="{A43ED200-5BED-24E1-B2F6-3FA7B4376B75}"/>
+              </a:ext>
+            </a:extLst>
+          </p:cNvPr>
           <p:cNvSpPr/>
           <p:nvPr/>
         </p:nvSpPr>
         <p:spPr>
           <a:xfrm>
             <a:off x="838200" y="3761556"/>
-            <a:ext cx="7093096" cy="1109663"/>
+            <a:ext cx="8020792" cy="1109663"/>
           </a:xfrm>
           <a:prstGeom prst="rect">
             <a:avLst/>
@@ -12429,26 +15478,7 @@
                 <a:ea typeface="Arial" pitchFamily="34" charset="-122"/>
                 <a:cs typeface="Arial" pitchFamily="34" charset="-120"/>
               </a:rPr>
-              <a:t>Turn a corpus of papers into a validated table with an LLM.</a:t>
-            </a:r>
-          </a:p>
-          <a:p>
-            <a:pPr marL="0" indent="0" algn="l">
-              <a:lnSpc>
-                <a:spcPct val="150000"/>
-              </a:lnSpc>
-              <a:buNone/>
-            </a:pPr>
-            <a:r>
-              <a:rPr lang="en-US" sz="1875" dirty="0">
-                <a:solidFill>
-                  <a:srgbClr val="E7C9C5"/>
-                </a:solidFill>
-                <a:latin typeface="Arial" pitchFamily="34" charset="0"/>
-                <a:ea typeface="Arial" pitchFamily="34" charset="-122"/>
-                <a:cs typeface="Arial" pitchFamily="34" charset="-120"/>
-              </a:rPr>
-              <a:t>With auto prompt optimization applied. </a:t>
+              <a:t>A collection of other different chemistry/materials science related domains</a:t>
             </a:r>
             <a:endParaRPr lang="en-US" sz="1875" dirty="0"/>
           </a:p>
@@ -12456,157 +15486,13 @@
       </p:sp>
       <p:sp>
         <p:nvSpPr>
-          <p:cNvPr id="8" name="Shape 6"/>
-          <p:cNvSpPr/>
-          <p:nvPr/>
-        </p:nvSpPr>
-        <p:spPr>
-          <a:xfrm>
-            <a:off x="838200" y="5214119"/>
-            <a:ext cx="2753171" cy="376238"/>
-          </a:xfrm>
-          <a:prstGeom prst="roundRect">
-            <a:avLst>
-              <a:gd name="adj" fmla="val 50000"/>
-            </a:avLst>
-          </a:prstGeom>
-          <a:solidFill>
-            <a:srgbClr val="EAAA00">
-              <a:alpha val="16000"/>
-            </a:srgbClr>
-          </a:solidFill>
-          <a:ln/>
-        </p:spPr>
-        <p:txBody>
-          <a:bodyPr/>
-          <a:lstStyle/>
-          <a:p>
-            <a:endParaRPr lang="en-US"/>
-          </a:p>
-        </p:txBody>
-      </p:sp>
-      <p:sp>
-        <p:nvSpPr>
-          <p:cNvPr id="9" name="Text 7"/>
-          <p:cNvSpPr/>
-          <p:nvPr/>
-        </p:nvSpPr>
-        <p:spPr>
-          <a:xfrm>
-            <a:off x="990600" y="5280794"/>
-            <a:ext cx="2530967" cy="280988"/>
-          </a:xfrm>
-          <a:prstGeom prst="rect">
-            <a:avLst/>
-          </a:prstGeom>
-          <a:noFill/>
-          <a:ln/>
-        </p:spPr>
-        <p:txBody>
-          <a:bodyPr wrap="square" lIns="25400" tIns="25400" rIns="25400" bIns="25400" rtlCol="0" anchor="t">
-            <a:normAutofit fontScale="92500" lnSpcReduction="20000"/>
-          </a:bodyPr>
-          <a:lstStyle/>
-          <a:p>
-            <a:pPr marL="0" indent="0" algn="l">
-              <a:lnSpc>
-                <a:spcPct val="150000"/>
-              </a:lnSpc>
-              <a:buNone/>
-            </a:pPr>
-            <a:r>
-              <a:rPr lang="en-US" sz="1275" kern="0" spc="38" dirty="0">
-                <a:solidFill>
-                  <a:srgbClr val="EAAA00"/>
-                </a:solidFill>
-                <a:latin typeface="IBM Plex Mono" pitchFamily="34" charset="0"/>
-                <a:ea typeface="IBM Plex Mono" pitchFamily="34" charset="-122"/>
-                <a:cs typeface="IBM Plex Mono" pitchFamily="34" charset="-120"/>
-              </a:rPr>
-              <a:t>150 FET-biosensor papers</a:t>
-            </a:r>
-            <a:endParaRPr lang="en-US" sz="1275" dirty="0"/>
-          </a:p>
-        </p:txBody>
-      </p:sp>
-      <p:sp>
-        <p:nvSpPr>
-          <p:cNvPr id="10" name="Shape 8"/>
-          <p:cNvSpPr/>
-          <p:nvPr/>
-        </p:nvSpPr>
-        <p:spPr>
-          <a:xfrm>
-            <a:off x="3686621" y="5214119"/>
-            <a:ext cx="1120973" cy="376238"/>
-          </a:xfrm>
-          <a:prstGeom prst="roundRect">
-            <a:avLst>
-              <a:gd name="adj" fmla="val 50000"/>
-            </a:avLst>
-          </a:prstGeom>
-          <a:solidFill>
-            <a:srgbClr val="EAAA00">
-              <a:alpha val="16000"/>
-            </a:srgbClr>
-          </a:solidFill>
-          <a:ln/>
-        </p:spPr>
-        <p:txBody>
-          <a:bodyPr/>
-          <a:lstStyle/>
-          <a:p>
-            <a:endParaRPr lang="en-US"/>
-          </a:p>
-        </p:txBody>
-      </p:sp>
-      <p:sp>
-        <p:nvSpPr>
-          <p:cNvPr id="11" name="Text 9"/>
-          <p:cNvSpPr/>
-          <p:nvPr/>
-        </p:nvSpPr>
-        <p:spPr>
-          <a:xfrm>
-            <a:off x="3839021" y="5280794"/>
-            <a:ext cx="892373" cy="280988"/>
-          </a:xfrm>
-          <a:prstGeom prst="rect">
-            <a:avLst/>
-          </a:prstGeom>
-          <a:noFill/>
-          <a:ln/>
-        </p:spPr>
-        <p:txBody>
-          <a:bodyPr wrap="square" lIns="25400" tIns="25400" rIns="25400" bIns="25400" rtlCol="0" anchor="t">
-            <a:normAutofit fontScale="92500" lnSpcReduction="20000"/>
-          </a:bodyPr>
-          <a:lstStyle/>
-          <a:p>
-            <a:pPr marL="0" indent="0" algn="l">
-              <a:lnSpc>
-                <a:spcPct val="150000"/>
-              </a:lnSpc>
-              <a:buNone/>
-            </a:pPr>
-            <a:r>
-              <a:rPr lang="en-US" sz="1275" kern="0" spc="38" dirty="0">
-                <a:solidFill>
-                  <a:srgbClr val="EAAA00"/>
-                </a:solidFill>
-                <a:latin typeface="IBM Plex Mono" pitchFamily="34" charset="0"/>
-                <a:ea typeface="IBM Plex Mono" pitchFamily="34" charset="-122"/>
-                <a:cs typeface="IBM Plex Mono" pitchFamily="34" charset="-120"/>
-              </a:rPr>
-              <a:t>8 fields</a:t>
-            </a:r>
-            <a:endParaRPr lang="en-US" sz="1275" dirty="0"/>
-          </a:p>
-        </p:txBody>
-      </p:sp>
-      <p:sp>
-        <p:nvSpPr>
-          <p:cNvPr id="14" name="Shape 12"/>
+          <p:cNvPr id="14" name="Shape 12">
+            <a:extLst>
+              <a:ext uri="{FF2B5EF4-FFF2-40B4-BE49-F238E27FC236}">
+                <a16:creationId xmlns:a16="http://schemas.microsoft.com/office/drawing/2014/main" id="{5347A07E-939B-2521-1FEB-09037D46899B}"/>
+              </a:ext>
+            </a:extLst>
+          </p:cNvPr>
           <p:cNvSpPr/>
           <p:nvPr/>
         </p:nvSpPr>
@@ -12635,7 +15521,13 @@
       </p:sp>
       <p:sp>
         <p:nvSpPr>
-          <p:cNvPr id="15" name="Text 13"/>
+          <p:cNvPr id="15" name="Text 13">
+            <a:extLst>
+              <a:ext uri="{FF2B5EF4-FFF2-40B4-BE49-F238E27FC236}">
+                <a16:creationId xmlns:a16="http://schemas.microsoft.com/office/drawing/2014/main" id="{3E6CA47F-165A-6ADA-5897-92B1AB9B3201}"/>
+              </a:ext>
+            </a:extLst>
+          </p:cNvPr>
           <p:cNvSpPr/>
           <p:nvPr/>
         </p:nvSpPr>
@@ -12679,14 +15571,20 @@
       </p:sp>
       <p:sp>
         <p:nvSpPr>
-          <p:cNvPr id="16" name="Text 14"/>
-          <p:cNvSpPr/>
-          <p:nvPr/>
-        </p:nvSpPr>
-        <p:spPr>
-          <a:xfrm>
-            <a:off x="9166845" y="6319838"/>
-            <a:ext cx="2339355" cy="252413"/>
+          <p:cNvPr id="16" name="Text 14">
+            <a:extLst>
+              <a:ext uri="{FF2B5EF4-FFF2-40B4-BE49-F238E27FC236}">
+                <a16:creationId xmlns:a16="http://schemas.microsoft.com/office/drawing/2014/main" id="{3CED5EBB-FF06-B101-6DA8-86F263F62849}"/>
+              </a:ext>
+            </a:extLst>
+          </p:cNvPr>
+          <p:cNvSpPr/>
+          <p:nvPr/>
+        </p:nvSpPr>
+        <p:spPr>
+          <a:xfrm>
+            <a:off x="9449693" y="6319838"/>
+            <a:ext cx="2056507" cy="252413"/>
           </a:xfrm>
           <a:prstGeom prst="rect">
             <a:avLst/>
@@ -12715,13 +15613,18 @@
                 <a:ea typeface="IBM Plex Mono" pitchFamily="34" charset="-122"/>
                 <a:cs typeface="IBM Plex Mono" pitchFamily="34" charset="-120"/>
               </a:rPr>
-              <a:t>Module 2a — Text to data</a:t>
+              <a:t>Module 1b — Stability</a:t>
             </a:r>
             <a:endParaRPr lang="en-US" sz="1125" dirty="0"/>
           </a:p>
         </p:txBody>
       </p:sp>
     </p:spTree>
+    <p:extLst>
+      <p:ext uri="{BB962C8B-B14F-4D97-AF65-F5344CB8AC3E}">
+        <p14:creationId xmlns:p14="http://schemas.microsoft.com/office/powerpoint/2010/main" val="2651848765"/>
+      </p:ext>
+    </p:extLst>
   </p:cSld>
   <p:clrMapOvr>
     <a:masterClrMapping/>

</xml_diff>